<commit_message>
Add founding team slide with CEO LinkedIn
Co-authored-by: mthak <mthak@users.noreply.github.com>
</commit_message>
<xml_diff>
--- a/RiseWise_Full_Investor_Deck.pptx
+++ b/RiseWise_Full_Investor_Deck.pptx
@@ -14,6 +14,7 @@
     <p:sldId id="262" r:id="rId13"/>
     <p:sldId id="263" r:id="rId14"/>
     <p:sldId id="264" r:id="rId15"/>
+    <p:sldId id="265" r:id="rId16"/>
   </p:sldIdLst>
   <p:sldSz cx="12191695" cy="6858000" type="screen4x3"/>
   <p:notesSz cx="6858000" cy="9144000"/>
@@ -3268,6 +3269,213 @@
             </a:pPr>
             <a:r>
               <a:t>• The Edge: Seamless progression from basic savings to advanced options.</a:t>
+            </a:r>
+          </a:p>
+        </p:txBody>
+      </p:sp>
+    </p:spTree>
+  </p:cSld>
+  <p:clrMapOvr>
+    <a:masterClrMapping/>
+  </p:clrMapOvr>
+</p:sld>
+</file>
+
+<file path=ppt/slides/slide10.xml><?xml version="1.0" encoding="utf-8"?>
+<p:sld xmlns:a="http://schemas.openxmlformats.org/drawingml/2006/main" xmlns:p="http://schemas.openxmlformats.org/presentationml/2006/main" xmlns:r="http://schemas.openxmlformats.org/officeDocument/2006/relationships">
+  <p:cSld>
+    <p:bg>
+      <p:bgPr>
+        <a:solidFill>
+          <a:srgbClr val="0D1117"/>
+        </a:solidFill>
+        <a:effectLst/>
+      </p:bgPr>
+    </p:bg>
+    <p:spTree>
+      <p:nvGrpSpPr>
+        <p:cNvPr id="1" name=""/>
+        <p:cNvGrpSpPr/>
+        <p:nvPr/>
+      </p:nvGrpSpPr>
+      <p:grpSpPr/>
+      <p:sp>
+        <p:nvSpPr>
+          <p:cNvPr id="2" name="TextBox 1"/>
+          <p:cNvSpPr txBox="1"/>
+          <p:nvPr/>
+        </p:nvSpPr>
+        <p:spPr>
+          <a:xfrm>
+            <a:off x="685800" y="502920"/>
+            <a:ext cx="10789920" cy="1005840"/>
+          </a:xfrm>
+          <a:prstGeom prst="rect">
+            <a:avLst/>
+          </a:prstGeom>
+          <a:noFill/>
+        </p:spPr>
+        <p:txBody>
+          <a:bodyPr wrap="none">
+            <a:spAutoFit/>
+          </a:bodyPr>
+          <a:lstStyle/>
+          <a:p>
+            <a:pPr>
+              <a:defRPr sz="3400" b="1">
+                <a:solidFill>
+                  <a:srgbClr val="FFFFFF"/>
+                </a:solidFill>
+                <a:latin typeface="Arial"/>
+              </a:defRPr>
+            </a:pPr>
+            <a:r>
+              <a:t>Slide 10: Founding Team</a:t>
+            </a:r>
+          </a:p>
+        </p:txBody>
+      </p:sp>
+      <p:sp>
+        <p:nvSpPr>
+          <p:cNvPr id="3" name="TextBox 2"/>
+          <p:cNvSpPr txBox="1"/>
+          <p:nvPr/>
+        </p:nvSpPr>
+        <p:spPr>
+          <a:xfrm>
+            <a:off x="685800" y="1645920"/>
+            <a:ext cx="10789920" cy="4892040"/>
+          </a:xfrm>
+          <a:prstGeom prst="rect">
+            <a:avLst/>
+          </a:prstGeom>
+          <a:noFill/>
+        </p:spPr>
+        <p:txBody>
+          <a:bodyPr wrap="square" lIns="45720" rIns="45720">
+            <a:spAutoFit/>
+          </a:bodyPr>
+          <a:lstStyle/>
+          <a:p>
+            <a:pPr>
+              <a:spcAft>
+                <a:spcPts val="700"/>
+              </a:spcAft>
+              <a:defRPr sz="1700">
+                <a:solidFill>
+                  <a:srgbClr val="B4B9C3"/>
+                </a:solidFill>
+                <a:latin typeface="Arial"/>
+              </a:defRPr>
+            </a:pPr>
+            <a:r>
+              <a:t>Founder Spotlight</a:t>
+            </a:r>
+          </a:p>
+          <a:p>
+            <a:pPr>
+              <a:spcAft>
+                <a:spcPts val="700"/>
+              </a:spcAft>
+              <a:defRPr sz="1700">
+                <a:solidFill>
+                  <a:srgbClr val="B4B9C3"/>
+                </a:solidFill>
+                <a:latin typeface="Arial"/>
+              </a:defRPr>
+            </a:pPr>
+          </a:p>
+          <a:p>
+            <a:pPr>
+              <a:spcAft>
+                <a:spcPts val="700"/>
+              </a:spcAft>
+              <a:defRPr sz="1700">
+                <a:solidFill>
+                  <a:srgbClr val="B4B9C3"/>
+                </a:solidFill>
+                <a:latin typeface="Arial"/>
+              </a:defRPr>
+            </a:pPr>
+            <a:r>
+              <a:t>Manoj Thakkar - CEO &amp; Founder</a:t>
+            </a:r>
+          </a:p>
+          <a:p>
+            <a:pPr>
+              <a:spcAft>
+                <a:spcPts val="700"/>
+              </a:spcAft>
+              <a:defRPr sz="1700">
+                <a:solidFill>
+                  <a:srgbClr val="B4B9C3"/>
+                </a:solidFill>
+                <a:latin typeface="Arial"/>
+              </a:defRPr>
+            </a:pPr>
+            <a:r>
+              <a:t>LinkedIn: https://www.linkedin.com/in/manoj-thakkar-6583b46/</a:t>
+            </a:r>
+          </a:p>
+          <a:p>
+            <a:pPr>
+              <a:spcAft>
+                <a:spcPts val="700"/>
+              </a:spcAft>
+              <a:defRPr sz="1700">
+                <a:solidFill>
+                  <a:srgbClr val="B4B9C3"/>
+                </a:solidFill>
+                <a:latin typeface="Arial"/>
+              </a:defRPr>
+            </a:pPr>
+          </a:p>
+          <a:p>
+            <a:pPr>
+              <a:spcAft>
+                <a:spcPts val="700"/>
+              </a:spcAft>
+              <a:defRPr sz="1700">
+                <a:solidFill>
+                  <a:srgbClr val="B4B9C3"/>
+                </a:solidFill>
+                <a:latin typeface="Arial"/>
+              </a:defRPr>
+            </a:pPr>
+            <a:r>
+              <a:t>Leadership Focus:</a:t>
+            </a:r>
+          </a:p>
+          <a:p>
+            <a:pPr>
+              <a:spcAft>
+                <a:spcPts val="700"/>
+              </a:spcAft>
+              <a:defRPr sz="1700">
+                <a:solidFill>
+                  <a:srgbClr val="B4B9C3"/>
+                </a:solidFill>
+                <a:latin typeface="Arial"/>
+              </a:defRPr>
+            </a:pPr>
+            <a:r>
+              <a:t>• Product vision for India's youth-first wealth platform.</a:t>
+            </a:r>
+          </a:p>
+          <a:p>
+            <a:pPr>
+              <a:spcAft>
+                <a:spcPts val="700"/>
+              </a:spcAft>
+              <a:defRPr sz="1700">
+                <a:solidFill>
+                  <a:srgbClr val="B4B9C3"/>
+                </a:solidFill>
+                <a:latin typeface="Arial"/>
+              </a:defRPr>
+            </a:pPr>
+            <a:r>
+              <a:t>• Execution across gamification, fintech partnerships, and growth.</a:t>
             </a:r>
           </a:p>
         </p:txBody>

</xml_diff>

<commit_message>
Add co-founders to founding team slide
Co-authored-by: mthak <mthak@users.noreply.github.com>
</commit_message>
<xml_diff>
--- a/RiseWise_Full_Investor_Deck.pptx
+++ b/RiseWise_Full_Investor_Deck.pptx
@@ -3369,7 +3369,7 @@
               </a:defRPr>
             </a:pPr>
             <a:r>
-              <a:t>Founder Spotlight</a:t>
+              <a:t>Founding Team Spotlight</a:t>
             </a:r>
           </a:p>
           <a:p>
@@ -3443,6 +3443,96 @@
               </a:defRPr>
             </a:pPr>
             <a:r>
+              <a:t>Nikunj Dewan - Co-Founder</a:t>
+            </a:r>
+          </a:p>
+          <a:p>
+            <a:pPr>
+              <a:spcAft>
+                <a:spcPts val="700"/>
+              </a:spcAft>
+              <a:defRPr sz="1700">
+                <a:solidFill>
+                  <a:srgbClr val="B4B9C3"/>
+                </a:solidFill>
+                <a:latin typeface="Arial"/>
+              </a:defRPr>
+            </a:pPr>
+            <a:r>
+              <a:t>LinkedIn: https://www.linkedin.com/in/nikunjdewan/</a:t>
+            </a:r>
+          </a:p>
+          <a:p>
+            <a:pPr>
+              <a:spcAft>
+                <a:spcPts val="700"/>
+              </a:spcAft>
+              <a:defRPr sz="1700">
+                <a:solidFill>
+                  <a:srgbClr val="B4B9C3"/>
+                </a:solidFill>
+                <a:latin typeface="Arial"/>
+              </a:defRPr>
+            </a:pPr>
+          </a:p>
+          <a:p>
+            <a:pPr>
+              <a:spcAft>
+                <a:spcPts val="700"/>
+              </a:spcAft>
+              <a:defRPr sz="1700">
+                <a:solidFill>
+                  <a:srgbClr val="B4B9C3"/>
+                </a:solidFill>
+                <a:latin typeface="Arial"/>
+              </a:defRPr>
+            </a:pPr>
+            <a:r>
+              <a:t>Janya Goel - Co-Founder</a:t>
+            </a:r>
+          </a:p>
+          <a:p>
+            <a:pPr>
+              <a:spcAft>
+                <a:spcPts val="700"/>
+              </a:spcAft>
+              <a:defRPr sz="1700">
+                <a:solidFill>
+                  <a:srgbClr val="B4B9C3"/>
+                </a:solidFill>
+                <a:latin typeface="Arial"/>
+              </a:defRPr>
+            </a:pPr>
+            <a:r>
+              <a:t>LinkedIn: https://www.linkedin.com/in/janyagoel/</a:t>
+            </a:r>
+          </a:p>
+          <a:p>
+            <a:pPr>
+              <a:spcAft>
+                <a:spcPts val="700"/>
+              </a:spcAft>
+              <a:defRPr sz="1700">
+                <a:solidFill>
+                  <a:srgbClr val="B4B9C3"/>
+                </a:solidFill>
+                <a:latin typeface="Arial"/>
+              </a:defRPr>
+            </a:pPr>
+          </a:p>
+          <a:p>
+            <a:pPr>
+              <a:spcAft>
+                <a:spcPts val="700"/>
+              </a:spcAft>
+              <a:defRPr sz="1700">
+                <a:solidFill>
+                  <a:srgbClr val="B4B9C3"/>
+                </a:solidFill>
+                <a:latin typeface="Arial"/>
+              </a:defRPr>
+            </a:pPr>
+            <a:r>
               <a:t>Leadership Focus:</a:t>
             </a:r>
           </a:p>
@@ -3476,6 +3566,22 @@
             </a:pPr>
             <a:r>
               <a:t>• Execution across gamification, fintech partnerships, and growth.</a:t>
+            </a:r>
+          </a:p>
+          <a:p>
+            <a:pPr>
+              <a:spcAft>
+                <a:spcPts val="700"/>
+              </a:spcAft>
+              <a:defRPr sz="1700">
+                <a:solidFill>
+                  <a:srgbClr val="B4B9C3"/>
+                </a:solidFill>
+                <a:latin typeface="Arial"/>
+              </a:defRPr>
+            </a:pPr>
+            <a:r>
+              <a:t>• Building a multi-disciplinary founding team with product and growth depth.</a:t>
             </a:r>
           </a:p>
         </p:txBody>

</xml_diff>

<commit_message>
Add traction and 12-month projection slide
Co-authored-by: mthak <mthak@users.noreply.github.com>
</commit_message>
<xml_diff>
--- a/RiseWise_Full_Investor_Deck.pptx
+++ b/RiseWise_Full_Investor_Deck.pptx
@@ -15,6 +15,7 @@
     <p:sldId id="263" r:id="rId14"/>
     <p:sldId id="264" r:id="rId15"/>
     <p:sldId id="265" r:id="rId16"/>
+    <p:sldId id="266" r:id="rId17"/>
   </p:sldIdLst>
   <p:sldSz cx="12191695" cy="6858000" type="screen4x3"/>
   <p:notesSz cx="6858000" cy="9144000"/>
@@ -3582,6 +3583,200 @@
             </a:pPr>
             <a:r>
               <a:t>• Building a multi-disciplinary founding team with product and growth depth.</a:t>
+            </a:r>
+          </a:p>
+        </p:txBody>
+      </p:sp>
+    </p:spTree>
+  </p:cSld>
+  <p:clrMapOvr>
+    <a:masterClrMapping/>
+  </p:clrMapOvr>
+</p:sld>
+</file>
+
+<file path=ppt/slides/slide11.xml><?xml version="1.0" encoding="utf-8"?>
+<p:sld xmlns:a="http://schemas.openxmlformats.org/drawingml/2006/main" xmlns:p="http://schemas.openxmlformats.org/presentationml/2006/main" xmlns:r="http://schemas.openxmlformats.org/officeDocument/2006/relationships">
+  <p:cSld>
+    <p:bg>
+      <p:bgPr>
+        <a:solidFill>
+          <a:srgbClr val="0D1117"/>
+        </a:solidFill>
+        <a:effectLst/>
+      </p:bgPr>
+    </p:bg>
+    <p:spTree>
+      <p:nvGrpSpPr>
+        <p:cNvPr id="1" name=""/>
+        <p:cNvGrpSpPr/>
+        <p:nvPr/>
+      </p:nvGrpSpPr>
+      <p:grpSpPr/>
+      <p:sp>
+        <p:nvSpPr>
+          <p:cNvPr id="2" name="TextBox 1"/>
+          <p:cNvSpPr txBox="1"/>
+          <p:nvPr/>
+        </p:nvSpPr>
+        <p:spPr>
+          <a:xfrm>
+            <a:off x="685800" y="502920"/>
+            <a:ext cx="10789920" cy="1005840"/>
+          </a:xfrm>
+          <a:prstGeom prst="rect">
+            <a:avLst/>
+          </a:prstGeom>
+          <a:noFill/>
+        </p:spPr>
+        <p:txBody>
+          <a:bodyPr wrap="none">
+            <a:spAutoFit/>
+          </a:bodyPr>
+          <a:lstStyle/>
+          <a:p>
+            <a:pPr>
+              <a:defRPr sz="3400" b="1">
+                <a:solidFill>
+                  <a:srgbClr val="FFFFFF"/>
+                </a:solidFill>
+                <a:latin typeface="Arial"/>
+              </a:defRPr>
+            </a:pPr>
+            <a:r>
+              <a:t>Slide 11: Traction and 12-Month Projection</a:t>
+            </a:r>
+          </a:p>
+        </p:txBody>
+      </p:sp>
+      <p:sp>
+        <p:nvSpPr>
+          <p:cNvPr id="3" name="TextBox 2"/>
+          <p:cNvSpPr txBox="1"/>
+          <p:nvPr/>
+        </p:nvSpPr>
+        <p:spPr>
+          <a:xfrm>
+            <a:off x="685800" y="1645920"/>
+            <a:ext cx="10789920" cy="4892040"/>
+          </a:xfrm>
+          <a:prstGeom prst="rect">
+            <a:avLst/>
+          </a:prstGeom>
+          <a:noFill/>
+        </p:spPr>
+        <p:txBody>
+          <a:bodyPr wrap="square" lIns="45720" rIns="45720">
+            <a:spAutoFit/>
+          </a:bodyPr>
+          <a:lstStyle/>
+          <a:p>
+            <a:pPr>
+              <a:spcAft>
+                <a:spcPts val="700"/>
+              </a:spcAft>
+              <a:defRPr sz="1700">
+                <a:solidFill>
+                  <a:srgbClr val="B4B9C3"/>
+                </a:solidFill>
+                <a:latin typeface="Arial"/>
+              </a:defRPr>
+            </a:pPr>
+            <a:r>
+              <a:t>Current Stage: Early Beta Traction</a:t>
+            </a:r>
+          </a:p>
+          <a:p>
+            <a:pPr>
+              <a:spcAft>
+                <a:spcPts val="700"/>
+              </a:spcAft>
+              <a:defRPr sz="1700">
+                <a:solidFill>
+                  <a:srgbClr val="B4B9C3"/>
+                </a:solidFill>
+                <a:latin typeface="Arial"/>
+              </a:defRPr>
+            </a:pPr>
+            <a:r>
+              <a:t>• Product status: Beta build completed.</a:t>
+            </a:r>
+          </a:p>
+          <a:p>
+            <a:pPr>
+              <a:spcAft>
+                <a:spcPts val="700"/>
+              </a:spcAft>
+              <a:defRPr sz="1700">
+                <a:solidFill>
+                  <a:srgbClr val="B4B9C3"/>
+                </a:solidFill>
+                <a:latin typeface="Arial"/>
+              </a:defRPr>
+            </a:pPr>
+            <a:r>
+              <a:t>• Current customer base: 50 early customers.</a:t>
+            </a:r>
+          </a:p>
+          <a:p>
+            <a:pPr>
+              <a:spcAft>
+                <a:spcPts val="700"/>
+              </a:spcAft>
+              <a:defRPr sz="1700">
+                <a:solidFill>
+                  <a:srgbClr val="B4B9C3"/>
+                </a:solidFill>
+                <a:latin typeface="Arial"/>
+              </a:defRPr>
+            </a:pPr>
+          </a:p>
+          <a:p>
+            <a:pPr>
+              <a:spcAft>
+                <a:spcPts val="700"/>
+              </a:spcAft>
+              <a:defRPr sz="1700">
+                <a:solidFill>
+                  <a:srgbClr val="B4B9C3"/>
+                </a:solidFill>
+                <a:latin typeface="Arial"/>
+              </a:defRPr>
+            </a:pPr>
+            <a:r>
+              <a:t>12-Month Projection:</a:t>
+            </a:r>
+          </a:p>
+          <a:p>
+            <a:pPr>
+              <a:spcAft>
+                <a:spcPts val="700"/>
+              </a:spcAft>
+              <a:defRPr sz="1700">
+                <a:solidFill>
+                  <a:srgbClr val="B4B9C3"/>
+                </a:solidFill>
+                <a:latin typeface="Arial"/>
+              </a:defRPr>
+            </a:pPr>
+            <a:r>
+              <a:t>• Target onboarding: 1 lakh (100,000) students.</a:t>
+            </a:r>
+          </a:p>
+          <a:p>
+            <a:pPr>
+              <a:spcAft>
+                <a:spcPts val="700"/>
+              </a:spcAft>
+              <a:defRPr sz="1700">
+                <a:solidFill>
+                  <a:srgbClr val="B4B9C3"/>
+                </a:solidFill>
+                <a:latin typeface="Arial"/>
+              </a:defRPr>
+            </a:pPr>
+            <a:r>
+              <a:t>• Focus: campus-led acquisition, gamified retention loops, and referral growth.</a:t>
             </a:r>
           </a:p>
         </p:txBody>

</xml_diff>

<commit_message>
Regenerate investor deck with new visual theme
Co-authored-by: mthak <mthak@users.noreply.github.com>
</commit_message>
<xml_diff>
--- a/RiseWise_Full_Investor_Deck.pptx
+++ b/RiseWise_Full_Investor_Deck.pptx
@@ -3108,14 +3108,188 @@
       <p:grpSpPr/>
       <p:sp>
         <p:nvSpPr>
-          <p:cNvPr id="2" name="TextBox 1"/>
+          <p:cNvPr id="2" name="Rectangle 1"/>
+          <p:cNvSpPr/>
+          <p:nvPr/>
+        </p:nvSpPr>
+        <p:spPr>
+          <a:xfrm>
+            <a:off x="0" y="0"/>
+            <a:ext cx="12191695" cy="1051560"/>
+          </a:xfrm>
+          <a:prstGeom prst="rect">
+            <a:avLst/>
+          </a:prstGeom>
+          <a:solidFill>
+            <a:srgbClr val="121821"/>
+          </a:solidFill>
+          <a:ln>
+            <a:noFill/>
+          </a:ln>
+        </p:spPr>
+        <p:style>
+          <a:lnRef idx="1">
+            <a:schemeClr val="accent1"/>
+          </a:lnRef>
+          <a:fillRef idx="3">
+            <a:schemeClr val="accent1"/>
+          </a:fillRef>
+          <a:effectRef idx="2">
+            <a:schemeClr val="accent1"/>
+          </a:effectRef>
+          <a:fontRef idx="minor">
+            <a:schemeClr val="lt1"/>
+          </a:fontRef>
+        </p:style>
+        <p:txBody>
+          <a:bodyPr rtlCol="0" anchor="ctr"/>
+          <a:lstStyle/>
+          <a:p>
+            <a:pPr algn="ctr"/>
+          </a:p>
+        </p:txBody>
+      </p:sp>
+      <p:sp>
+        <p:nvSpPr>
+          <p:cNvPr id="3" name="Rectangle 2"/>
+          <p:cNvSpPr/>
+          <p:nvPr/>
+        </p:nvSpPr>
+        <p:spPr>
+          <a:xfrm>
+            <a:off x="0" y="0"/>
+            <a:ext cx="12191695" cy="73152"/>
+          </a:xfrm>
+          <a:prstGeom prst="rect">
+            <a:avLst/>
+          </a:prstGeom>
+          <a:solidFill>
+            <a:srgbClr val="00E676"/>
+          </a:solidFill>
+          <a:ln>
+            <a:noFill/>
+          </a:ln>
+        </p:spPr>
+        <p:style>
+          <a:lnRef idx="1">
+            <a:schemeClr val="accent1"/>
+          </a:lnRef>
+          <a:fillRef idx="3">
+            <a:schemeClr val="accent1"/>
+          </a:fillRef>
+          <a:effectRef idx="2">
+            <a:schemeClr val="accent1"/>
+          </a:effectRef>
+          <a:fontRef idx="minor">
+            <a:schemeClr val="lt1"/>
+          </a:fontRef>
+        </p:style>
+        <p:txBody>
+          <a:bodyPr rtlCol="0" anchor="ctr"/>
+          <a:lstStyle/>
+          <a:p>
+            <a:pPr algn="ctr"/>
+          </a:p>
+        </p:txBody>
+      </p:sp>
+      <p:sp>
+        <p:nvSpPr>
+          <p:cNvPr id="4" name="Rounded Rectangle 3"/>
+          <p:cNvSpPr/>
+          <p:nvPr/>
+        </p:nvSpPr>
+        <p:spPr>
+          <a:xfrm>
+            <a:off x="9784080" y="201168"/>
+            <a:ext cx="1691640" cy="502920"/>
+          </a:xfrm>
+          <a:prstGeom prst="roundRect">
+            <a:avLst/>
+          </a:prstGeom>
+          <a:solidFill>
+            <a:srgbClr val="388BFD"/>
+          </a:solidFill>
+          <a:ln>
+            <a:noFill/>
+          </a:ln>
+        </p:spPr>
+        <p:style>
+          <a:lnRef idx="1">
+            <a:schemeClr val="accent1"/>
+          </a:lnRef>
+          <a:fillRef idx="3">
+            <a:schemeClr val="accent1"/>
+          </a:fillRef>
+          <a:effectRef idx="2">
+            <a:schemeClr val="accent1"/>
+          </a:effectRef>
+          <a:fontRef idx="minor">
+            <a:schemeClr val="lt1"/>
+          </a:fontRef>
+        </p:style>
+        <p:txBody>
+          <a:bodyPr rtlCol="0" anchor="ctr"/>
+          <a:lstStyle/>
+          <a:p>
+            <a:pPr algn="ctr"/>
+          </a:p>
+        </p:txBody>
+      </p:sp>
+      <p:sp>
+        <p:nvSpPr>
+          <p:cNvPr id="5" name="Rounded Rectangle 4"/>
+          <p:cNvSpPr/>
+          <p:nvPr/>
+        </p:nvSpPr>
+        <p:spPr>
+          <a:xfrm>
+            <a:off x="502920" y="1325880"/>
+            <a:ext cx="11155680" cy="5257800"/>
+          </a:xfrm>
+          <a:prstGeom prst="roundRect">
+            <a:avLst/>
+          </a:prstGeom>
+          <a:solidFill>
+            <a:srgbClr val="161B22"/>
+          </a:solidFill>
+          <a:ln w="12700">
+            <a:solidFill>
+              <a:srgbClr val="308C64"/>
+            </a:solidFill>
+          </a:ln>
+        </p:spPr>
+        <p:style>
+          <a:lnRef idx="1">
+            <a:schemeClr val="accent1"/>
+          </a:lnRef>
+          <a:fillRef idx="3">
+            <a:schemeClr val="accent1"/>
+          </a:fillRef>
+          <a:effectRef idx="2">
+            <a:schemeClr val="accent1"/>
+          </a:effectRef>
+          <a:fontRef idx="minor">
+            <a:schemeClr val="lt1"/>
+          </a:fontRef>
+        </p:style>
+        <p:txBody>
+          <a:bodyPr rtlCol="0" anchor="ctr"/>
+          <a:lstStyle/>
+          <a:p>
+            <a:pPr algn="ctr"/>
+          </a:p>
+        </p:txBody>
+      </p:sp>
+      <p:sp>
+        <p:nvSpPr>
+          <p:cNvPr id="6" name="TextBox 5"/>
           <p:cNvSpPr txBox="1"/>
           <p:nvPr/>
         </p:nvSpPr>
         <p:spPr>
           <a:xfrm>
-            <a:off x="685800" y="502920"/>
-            <a:ext cx="10789920" cy="1005840"/>
+            <a:off x="713232" y="246888"/>
+            <a:ext cx="9692640" cy="777240"/>
           </a:xfrm>
           <a:prstGeom prst="rect">
             <a:avLst/>
@@ -3129,11 +3303,11 @@
           <a:lstStyle/>
           <a:p>
             <a:pPr>
-              <a:defRPr sz="3400" b="1">
+              <a:defRPr sz="3000" b="1">
                 <a:solidFill>
                   <a:srgbClr val="FFFFFF"/>
                 </a:solidFill>
-                <a:latin typeface="Arial"/>
+                <a:latin typeface="Calibri"/>
               </a:defRPr>
             </a:pPr>
             <a:r>
@@ -3144,14 +3318,14 @@
       </p:sp>
       <p:sp>
         <p:nvSpPr>
-          <p:cNvPr id="3" name="TextBox 2"/>
+          <p:cNvPr id="7" name="TextBox 6"/>
           <p:cNvSpPr txBox="1"/>
           <p:nvPr/>
         </p:nvSpPr>
         <p:spPr>
           <a:xfrm>
-            <a:off x="685800" y="1645920"/>
-            <a:ext cx="10789920" cy="4892040"/>
+            <a:off x="804672" y="1627632"/>
+            <a:ext cx="10561320" cy="4681728"/>
           </a:xfrm>
           <a:prstGeom prst="rect">
             <a:avLst/>
@@ -3166,13 +3340,13 @@
           <a:p>
             <a:pPr>
               <a:spcAft>
-                <a:spcPts val="700"/>
-              </a:spcAft>
-              <a:defRPr sz="2300" b="1">
+                <a:spcPts val="600"/>
+              </a:spcAft>
+              <a:defRPr sz="2200" b="1">
                 <a:solidFill>
                   <a:srgbClr val="00E676"/>
                 </a:solidFill>
-                <a:latin typeface="Arial"/>
+                <a:latin typeface="Calibri"/>
               </a:defRPr>
             </a:pPr>
             <a:r>
@@ -3182,13 +3356,13 @@
           <a:p>
             <a:pPr>
               <a:spcAft>
-                <a:spcPts val="700"/>
-              </a:spcAft>
-              <a:defRPr sz="1700">
-                <a:solidFill>
-                  <a:srgbClr val="B4B9C3"/>
-                </a:solidFill>
-                <a:latin typeface="Arial"/>
+                <a:spcPts val="600"/>
+              </a:spcAft>
+              <a:defRPr sz="1600">
+                <a:solidFill>
+                  <a:srgbClr val="C9D1D9"/>
+                </a:solidFill>
+                <a:latin typeface="Calibri"/>
               </a:defRPr>
             </a:pPr>
             <a:r>
@@ -3198,26 +3372,26 @@
           <a:p>
             <a:pPr>
               <a:spcAft>
-                <a:spcPts val="700"/>
-              </a:spcAft>
-              <a:defRPr sz="1700">
-                <a:solidFill>
-                  <a:srgbClr val="B4B9C3"/>
-                </a:solidFill>
-                <a:latin typeface="Arial"/>
-              </a:defRPr>
-            </a:pPr>
-          </a:p>
-          <a:p>
-            <a:pPr>
-              <a:spcAft>
-                <a:spcPts val="700"/>
-              </a:spcAft>
-              <a:defRPr sz="1700">
-                <a:solidFill>
-                  <a:srgbClr val="B4B9C3"/>
-                </a:solidFill>
-                <a:latin typeface="Arial"/>
+                <a:spcPts val="600"/>
+              </a:spcAft>
+              <a:defRPr sz="1600">
+                <a:solidFill>
+                  <a:srgbClr val="C9D1D9"/>
+                </a:solidFill>
+                <a:latin typeface="Calibri"/>
+              </a:defRPr>
+            </a:pPr>
+          </a:p>
+          <a:p>
+            <a:pPr>
+              <a:spcAft>
+                <a:spcPts val="600"/>
+              </a:spcAft>
+              <a:defRPr sz="1600">
+                <a:solidFill>
+                  <a:srgbClr val="C9D1D9"/>
+                </a:solidFill>
+                <a:latin typeface="Calibri"/>
               </a:defRPr>
             </a:pPr>
             <a:r>
@@ -3227,13 +3401,13 @@
           <a:p>
             <a:pPr>
               <a:spcAft>
-                <a:spcPts val="700"/>
-              </a:spcAft>
-              <a:defRPr sz="1700">
-                <a:solidFill>
-                  <a:srgbClr val="B4B9C3"/>
-                </a:solidFill>
-                <a:latin typeface="Arial"/>
+                <a:spcPts val="600"/>
+              </a:spcAft>
+              <a:defRPr sz="1600">
+                <a:solidFill>
+                  <a:srgbClr val="C9D1D9"/>
+                </a:solidFill>
+                <a:latin typeface="Calibri"/>
               </a:defRPr>
             </a:pPr>
             <a:r>
@@ -3243,13 +3417,13 @@
           <a:p>
             <a:pPr>
               <a:spcAft>
-                <a:spcPts val="700"/>
-              </a:spcAft>
-              <a:defRPr sz="1700">
-                <a:solidFill>
-                  <a:srgbClr val="B4B9C3"/>
-                </a:solidFill>
-                <a:latin typeface="Arial"/>
+                <a:spcPts val="600"/>
+              </a:spcAft>
+              <a:defRPr sz="1600">
+                <a:solidFill>
+                  <a:srgbClr val="C9D1D9"/>
+                </a:solidFill>
+                <a:latin typeface="Calibri"/>
               </a:defRPr>
             </a:pPr>
             <a:r>
@@ -3259,13 +3433,13 @@
           <a:p>
             <a:pPr>
               <a:spcAft>
-                <a:spcPts val="700"/>
-              </a:spcAft>
-              <a:defRPr sz="1700">
-                <a:solidFill>
-                  <a:srgbClr val="B4B9C3"/>
-                </a:solidFill>
-                <a:latin typeface="Arial"/>
+                <a:spcPts val="600"/>
+              </a:spcAft>
+              <a:defRPr sz="1600">
+                <a:solidFill>
+                  <a:srgbClr val="C9D1D9"/>
+                </a:solidFill>
+                <a:latin typeface="Calibri"/>
               </a:defRPr>
             </a:pPr>
             <a:r>
@@ -3302,14 +3476,188 @@
       <p:grpSpPr/>
       <p:sp>
         <p:nvSpPr>
-          <p:cNvPr id="2" name="TextBox 1"/>
+          <p:cNvPr id="2" name="Rectangle 1"/>
+          <p:cNvSpPr/>
+          <p:nvPr/>
+        </p:nvSpPr>
+        <p:spPr>
+          <a:xfrm>
+            <a:off x="0" y="0"/>
+            <a:ext cx="12191695" cy="1051560"/>
+          </a:xfrm>
+          <a:prstGeom prst="rect">
+            <a:avLst/>
+          </a:prstGeom>
+          <a:solidFill>
+            <a:srgbClr val="121821"/>
+          </a:solidFill>
+          <a:ln>
+            <a:noFill/>
+          </a:ln>
+        </p:spPr>
+        <p:style>
+          <a:lnRef idx="1">
+            <a:schemeClr val="accent1"/>
+          </a:lnRef>
+          <a:fillRef idx="3">
+            <a:schemeClr val="accent1"/>
+          </a:fillRef>
+          <a:effectRef idx="2">
+            <a:schemeClr val="accent1"/>
+          </a:effectRef>
+          <a:fontRef idx="minor">
+            <a:schemeClr val="lt1"/>
+          </a:fontRef>
+        </p:style>
+        <p:txBody>
+          <a:bodyPr rtlCol="0" anchor="ctr"/>
+          <a:lstStyle/>
+          <a:p>
+            <a:pPr algn="ctr"/>
+          </a:p>
+        </p:txBody>
+      </p:sp>
+      <p:sp>
+        <p:nvSpPr>
+          <p:cNvPr id="3" name="Rectangle 2"/>
+          <p:cNvSpPr/>
+          <p:nvPr/>
+        </p:nvSpPr>
+        <p:spPr>
+          <a:xfrm>
+            <a:off x="0" y="0"/>
+            <a:ext cx="12191695" cy="73152"/>
+          </a:xfrm>
+          <a:prstGeom prst="rect">
+            <a:avLst/>
+          </a:prstGeom>
+          <a:solidFill>
+            <a:srgbClr val="00E676"/>
+          </a:solidFill>
+          <a:ln>
+            <a:noFill/>
+          </a:ln>
+        </p:spPr>
+        <p:style>
+          <a:lnRef idx="1">
+            <a:schemeClr val="accent1"/>
+          </a:lnRef>
+          <a:fillRef idx="3">
+            <a:schemeClr val="accent1"/>
+          </a:fillRef>
+          <a:effectRef idx="2">
+            <a:schemeClr val="accent1"/>
+          </a:effectRef>
+          <a:fontRef idx="minor">
+            <a:schemeClr val="lt1"/>
+          </a:fontRef>
+        </p:style>
+        <p:txBody>
+          <a:bodyPr rtlCol="0" anchor="ctr"/>
+          <a:lstStyle/>
+          <a:p>
+            <a:pPr algn="ctr"/>
+          </a:p>
+        </p:txBody>
+      </p:sp>
+      <p:sp>
+        <p:nvSpPr>
+          <p:cNvPr id="4" name="Rounded Rectangle 3"/>
+          <p:cNvSpPr/>
+          <p:nvPr/>
+        </p:nvSpPr>
+        <p:spPr>
+          <a:xfrm>
+            <a:off x="9784080" y="201168"/>
+            <a:ext cx="1691640" cy="502920"/>
+          </a:xfrm>
+          <a:prstGeom prst="roundRect">
+            <a:avLst/>
+          </a:prstGeom>
+          <a:solidFill>
+            <a:srgbClr val="388BFD"/>
+          </a:solidFill>
+          <a:ln>
+            <a:noFill/>
+          </a:ln>
+        </p:spPr>
+        <p:style>
+          <a:lnRef idx="1">
+            <a:schemeClr val="accent1"/>
+          </a:lnRef>
+          <a:fillRef idx="3">
+            <a:schemeClr val="accent1"/>
+          </a:fillRef>
+          <a:effectRef idx="2">
+            <a:schemeClr val="accent1"/>
+          </a:effectRef>
+          <a:fontRef idx="minor">
+            <a:schemeClr val="lt1"/>
+          </a:fontRef>
+        </p:style>
+        <p:txBody>
+          <a:bodyPr rtlCol="0" anchor="ctr"/>
+          <a:lstStyle/>
+          <a:p>
+            <a:pPr algn="ctr"/>
+          </a:p>
+        </p:txBody>
+      </p:sp>
+      <p:sp>
+        <p:nvSpPr>
+          <p:cNvPr id="5" name="Rounded Rectangle 4"/>
+          <p:cNvSpPr/>
+          <p:nvPr/>
+        </p:nvSpPr>
+        <p:spPr>
+          <a:xfrm>
+            <a:off x="502920" y="1325880"/>
+            <a:ext cx="11155680" cy="5257800"/>
+          </a:xfrm>
+          <a:prstGeom prst="roundRect">
+            <a:avLst/>
+          </a:prstGeom>
+          <a:solidFill>
+            <a:srgbClr val="161B22"/>
+          </a:solidFill>
+          <a:ln w="12700">
+            <a:solidFill>
+              <a:srgbClr val="308C64"/>
+            </a:solidFill>
+          </a:ln>
+        </p:spPr>
+        <p:style>
+          <a:lnRef idx="1">
+            <a:schemeClr val="accent1"/>
+          </a:lnRef>
+          <a:fillRef idx="3">
+            <a:schemeClr val="accent1"/>
+          </a:fillRef>
+          <a:effectRef idx="2">
+            <a:schemeClr val="accent1"/>
+          </a:effectRef>
+          <a:fontRef idx="minor">
+            <a:schemeClr val="lt1"/>
+          </a:fontRef>
+        </p:style>
+        <p:txBody>
+          <a:bodyPr rtlCol="0" anchor="ctr"/>
+          <a:lstStyle/>
+          <a:p>
+            <a:pPr algn="ctr"/>
+          </a:p>
+        </p:txBody>
+      </p:sp>
+      <p:sp>
+        <p:nvSpPr>
+          <p:cNvPr id="6" name="TextBox 5"/>
           <p:cNvSpPr txBox="1"/>
           <p:nvPr/>
         </p:nvSpPr>
         <p:spPr>
           <a:xfrm>
-            <a:off x="685800" y="502920"/>
-            <a:ext cx="10789920" cy="1005840"/>
+            <a:off x="713232" y="246888"/>
+            <a:ext cx="9692640" cy="777240"/>
           </a:xfrm>
           <a:prstGeom prst="rect">
             <a:avLst/>
@@ -3323,11 +3671,11 @@
           <a:lstStyle/>
           <a:p>
             <a:pPr>
-              <a:defRPr sz="3400" b="1">
+              <a:defRPr sz="3000" b="1">
                 <a:solidFill>
                   <a:srgbClr val="FFFFFF"/>
                 </a:solidFill>
-                <a:latin typeface="Arial"/>
+                <a:latin typeface="Calibri"/>
               </a:defRPr>
             </a:pPr>
             <a:r>
@@ -3338,14 +3686,14 @@
       </p:sp>
       <p:sp>
         <p:nvSpPr>
-          <p:cNvPr id="3" name="TextBox 2"/>
+          <p:cNvPr id="7" name="TextBox 6"/>
           <p:cNvSpPr txBox="1"/>
           <p:nvPr/>
         </p:nvSpPr>
         <p:spPr>
           <a:xfrm>
-            <a:off x="685800" y="1645920"/>
-            <a:ext cx="10789920" cy="4892040"/>
+            <a:off x="804672" y="1627632"/>
+            <a:ext cx="10561320" cy="4681728"/>
           </a:xfrm>
           <a:prstGeom prst="rect">
             <a:avLst/>
@@ -3360,13 +3708,13 @@
           <a:p>
             <a:pPr>
               <a:spcAft>
-                <a:spcPts val="700"/>
-              </a:spcAft>
-              <a:defRPr sz="1700">
-                <a:solidFill>
-                  <a:srgbClr val="B4B9C3"/>
-                </a:solidFill>
-                <a:latin typeface="Arial"/>
+                <a:spcPts val="600"/>
+              </a:spcAft>
+              <a:defRPr sz="1600">
+                <a:solidFill>
+                  <a:srgbClr val="C9D1D9"/>
+                </a:solidFill>
+                <a:latin typeface="Calibri"/>
               </a:defRPr>
             </a:pPr>
             <a:r>
@@ -3376,26 +3724,26 @@
           <a:p>
             <a:pPr>
               <a:spcAft>
-                <a:spcPts val="700"/>
-              </a:spcAft>
-              <a:defRPr sz="1700">
-                <a:solidFill>
-                  <a:srgbClr val="B4B9C3"/>
-                </a:solidFill>
-                <a:latin typeface="Arial"/>
-              </a:defRPr>
-            </a:pPr>
-          </a:p>
-          <a:p>
-            <a:pPr>
-              <a:spcAft>
-                <a:spcPts val="700"/>
-              </a:spcAft>
-              <a:defRPr sz="1700">
-                <a:solidFill>
-                  <a:srgbClr val="B4B9C3"/>
-                </a:solidFill>
-                <a:latin typeface="Arial"/>
+                <a:spcPts val="600"/>
+              </a:spcAft>
+              <a:defRPr sz="1600">
+                <a:solidFill>
+                  <a:srgbClr val="C9D1D9"/>
+                </a:solidFill>
+                <a:latin typeface="Calibri"/>
+              </a:defRPr>
+            </a:pPr>
+          </a:p>
+          <a:p>
+            <a:pPr>
+              <a:spcAft>
+                <a:spcPts val="600"/>
+              </a:spcAft>
+              <a:defRPr sz="1600">
+                <a:solidFill>
+                  <a:srgbClr val="C9D1D9"/>
+                </a:solidFill>
+                <a:latin typeface="Calibri"/>
               </a:defRPr>
             </a:pPr>
             <a:r>
@@ -3405,13 +3753,13 @@
           <a:p>
             <a:pPr>
               <a:spcAft>
-                <a:spcPts val="700"/>
-              </a:spcAft>
-              <a:defRPr sz="1700">
-                <a:solidFill>
-                  <a:srgbClr val="B4B9C3"/>
-                </a:solidFill>
-                <a:latin typeface="Arial"/>
+                <a:spcPts val="600"/>
+              </a:spcAft>
+              <a:defRPr sz="2200" b="1">
+                <a:solidFill>
+                  <a:srgbClr val="00E676"/>
+                </a:solidFill>
+                <a:latin typeface="Calibri"/>
               </a:defRPr>
             </a:pPr>
             <a:r>
@@ -3421,26 +3769,26 @@
           <a:p>
             <a:pPr>
               <a:spcAft>
-                <a:spcPts val="700"/>
-              </a:spcAft>
-              <a:defRPr sz="1700">
-                <a:solidFill>
-                  <a:srgbClr val="B4B9C3"/>
-                </a:solidFill>
-                <a:latin typeface="Arial"/>
-              </a:defRPr>
-            </a:pPr>
-          </a:p>
-          <a:p>
-            <a:pPr>
-              <a:spcAft>
-                <a:spcPts val="700"/>
-              </a:spcAft>
-              <a:defRPr sz="1700">
-                <a:solidFill>
-                  <a:srgbClr val="B4B9C3"/>
-                </a:solidFill>
-                <a:latin typeface="Arial"/>
+                <a:spcPts val="600"/>
+              </a:spcAft>
+              <a:defRPr sz="1600">
+                <a:solidFill>
+                  <a:srgbClr val="C9D1D9"/>
+                </a:solidFill>
+                <a:latin typeface="Calibri"/>
+              </a:defRPr>
+            </a:pPr>
+          </a:p>
+          <a:p>
+            <a:pPr>
+              <a:spcAft>
+                <a:spcPts val="600"/>
+              </a:spcAft>
+              <a:defRPr sz="1600">
+                <a:solidFill>
+                  <a:srgbClr val="C9D1D9"/>
+                </a:solidFill>
+                <a:latin typeface="Calibri"/>
               </a:defRPr>
             </a:pPr>
             <a:r>
@@ -3450,13 +3798,13 @@
           <a:p>
             <a:pPr>
               <a:spcAft>
-                <a:spcPts val="700"/>
-              </a:spcAft>
-              <a:defRPr sz="1700">
-                <a:solidFill>
-                  <a:srgbClr val="B4B9C3"/>
-                </a:solidFill>
-                <a:latin typeface="Arial"/>
+                <a:spcPts val="600"/>
+              </a:spcAft>
+              <a:defRPr sz="2200" b="1">
+                <a:solidFill>
+                  <a:srgbClr val="00E676"/>
+                </a:solidFill>
+                <a:latin typeface="Calibri"/>
               </a:defRPr>
             </a:pPr>
             <a:r>
@@ -3466,26 +3814,26 @@
           <a:p>
             <a:pPr>
               <a:spcAft>
-                <a:spcPts val="700"/>
-              </a:spcAft>
-              <a:defRPr sz="1700">
-                <a:solidFill>
-                  <a:srgbClr val="B4B9C3"/>
-                </a:solidFill>
-                <a:latin typeface="Arial"/>
-              </a:defRPr>
-            </a:pPr>
-          </a:p>
-          <a:p>
-            <a:pPr>
-              <a:spcAft>
-                <a:spcPts val="700"/>
-              </a:spcAft>
-              <a:defRPr sz="1700">
-                <a:solidFill>
-                  <a:srgbClr val="B4B9C3"/>
-                </a:solidFill>
-                <a:latin typeface="Arial"/>
+                <a:spcPts val="600"/>
+              </a:spcAft>
+              <a:defRPr sz="1600">
+                <a:solidFill>
+                  <a:srgbClr val="C9D1D9"/>
+                </a:solidFill>
+                <a:latin typeface="Calibri"/>
+              </a:defRPr>
+            </a:pPr>
+          </a:p>
+          <a:p>
+            <a:pPr>
+              <a:spcAft>
+                <a:spcPts val="600"/>
+              </a:spcAft>
+              <a:defRPr sz="1600">
+                <a:solidFill>
+                  <a:srgbClr val="C9D1D9"/>
+                </a:solidFill>
+                <a:latin typeface="Calibri"/>
               </a:defRPr>
             </a:pPr>
             <a:r>
@@ -3495,13 +3843,13 @@
           <a:p>
             <a:pPr>
               <a:spcAft>
-                <a:spcPts val="700"/>
-              </a:spcAft>
-              <a:defRPr sz="1700">
-                <a:solidFill>
-                  <a:srgbClr val="B4B9C3"/>
-                </a:solidFill>
-                <a:latin typeface="Arial"/>
+                <a:spcPts val="600"/>
+              </a:spcAft>
+              <a:defRPr sz="2200" b="1">
+                <a:solidFill>
+                  <a:srgbClr val="00E676"/>
+                </a:solidFill>
+                <a:latin typeface="Calibri"/>
               </a:defRPr>
             </a:pPr>
             <a:r>
@@ -3511,26 +3859,26 @@
           <a:p>
             <a:pPr>
               <a:spcAft>
-                <a:spcPts val="700"/>
-              </a:spcAft>
-              <a:defRPr sz="1700">
-                <a:solidFill>
-                  <a:srgbClr val="B4B9C3"/>
-                </a:solidFill>
-                <a:latin typeface="Arial"/>
-              </a:defRPr>
-            </a:pPr>
-          </a:p>
-          <a:p>
-            <a:pPr>
-              <a:spcAft>
-                <a:spcPts val="700"/>
-              </a:spcAft>
-              <a:defRPr sz="1700">
-                <a:solidFill>
-                  <a:srgbClr val="B4B9C3"/>
-                </a:solidFill>
-                <a:latin typeface="Arial"/>
+                <a:spcPts val="600"/>
+              </a:spcAft>
+              <a:defRPr sz="1600">
+                <a:solidFill>
+                  <a:srgbClr val="C9D1D9"/>
+                </a:solidFill>
+                <a:latin typeface="Calibri"/>
+              </a:defRPr>
+            </a:pPr>
+          </a:p>
+          <a:p>
+            <a:pPr>
+              <a:spcAft>
+                <a:spcPts val="600"/>
+              </a:spcAft>
+              <a:defRPr sz="1600">
+                <a:solidFill>
+                  <a:srgbClr val="C9D1D9"/>
+                </a:solidFill>
+                <a:latin typeface="Calibri"/>
               </a:defRPr>
             </a:pPr>
             <a:r>
@@ -3540,13 +3888,13 @@
           <a:p>
             <a:pPr>
               <a:spcAft>
-                <a:spcPts val="700"/>
-              </a:spcAft>
-              <a:defRPr sz="1700">
-                <a:solidFill>
-                  <a:srgbClr val="B4B9C3"/>
-                </a:solidFill>
-                <a:latin typeface="Arial"/>
+                <a:spcPts val="600"/>
+              </a:spcAft>
+              <a:defRPr sz="1600">
+                <a:solidFill>
+                  <a:srgbClr val="C9D1D9"/>
+                </a:solidFill>
+                <a:latin typeface="Calibri"/>
               </a:defRPr>
             </a:pPr>
             <a:r>
@@ -3556,13 +3904,13 @@
           <a:p>
             <a:pPr>
               <a:spcAft>
-                <a:spcPts val="700"/>
-              </a:spcAft>
-              <a:defRPr sz="1700">
-                <a:solidFill>
-                  <a:srgbClr val="B4B9C3"/>
-                </a:solidFill>
-                <a:latin typeface="Arial"/>
+                <a:spcPts val="600"/>
+              </a:spcAft>
+              <a:defRPr sz="1600">
+                <a:solidFill>
+                  <a:srgbClr val="C9D1D9"/>
+                </a:solidFill>
+                <a:latin typeface="Calibri"/>
               </a:defRPr>
             </a:pPr>
             <a:r>
@@ -3572,13 +3920,13 @@
           <a:p>
             <a:pPr>
               <a:spcAft>
-                <a:spcPts val="700"/>
-              </a:spcAft>
-              <a:defRPr sz="1700">
-                <a:solidFill>
-                  <a:srgbClr val="B4B9C3"/>
-                </a:solidFill>
-                <a:latin typeface="Arial"/>
+                <a:spcPts val="600"/>
+              </a:spcAft>
+              <a:defRPr sz="1600">
+                <a:solidFill>
+                  <a:srgbClr val="C9D1D9"/>
+                </a:solidFill>
+                <a:latin typeface="Calibri"/>
               </a:defRPr>
             </a:pPr>
             <a:r>
@@ -3615,14 +3963,188 @@
       <p:grpSpPr/>
       <p:sp>
         <p:nvSpPr>
-          <p:cNvPr id="2" name="TextBox 1"/>
+          <p:cNvPr id="2" name="Rectangle 1"/>
+          <p:cNvSpPr/>
+          <p:nvPr/>
+        </p:nvSpPr>
+        <p:spPr>
+          <a:xfrm>
+            <a:off x="0" y="0"/>
+            <a:ext cx="12191695" cy="1051560"/>
+          </a:xfrm>
+          <a:prstGeom prst="rect">
+            <a:avLst/>
+          </a:prstGeom>
+          <a:solidFill>
+            <a:srgbClr val="121821"/>
+          </a:solidFill>
+          <a:ln>
+            <a:noFill/>
+          </a:ln>
+        </p:spPr>
+        <p:style>
+          <a:lnRef idx="1">
+            <a:schemeClr val="accent1"/>
+          </a:lnRef>
+          <a:fillRef idx="3">
+            <a:schemeClr val="accent1"/>
+          </a:fillRef>
+          <a:effectRef idx="2">
+            <a:schemeClr val="accent1"/>
+          </a:effectRef>
+          <a:fontRef idx="minor">
+            <a:schemeClr val="lt1"/>
+          </a:fontRef>
+        </p:style>
+        <p:txBody>
+          <a:bodyPr rtlCol="0" anchor="ctr"/>
+          <a:lstStyle/>
+          <a:p>
+            <a:pPr algn="ctr"/>
+          </a:p>
+        </p:txBody>
+      </p:sp>
+      <p:sp>
+        <p:nvSpPr>
+          <p:cNvPr id="3" name="Rectangle 2"/>
+          <p:cNvSpPr/>
+          <p:nvPr/>
+        </p:nvSpPr>
+        <p:spPr>
+          <a:xfrm>
+            <a:off x="0" y="0"/>
+            <a:ext cx="12191695" cy="73152"/>
+          </a:xfrm>
+          <a:prstGeom prst="rect">
+            <a:avLst/>
+          </a:prstGeom>
+          <a:solidFill>
+            <a:srgbClr val="00E676"/>
+          </a:solidFill>
+          <a:ln>
+            <a:noFill/>
+          </a:ln>
+        </p:spPr>
+        <p:style>
+          <a:lnRef idx="1">
+            <a:schemeClr val="accent1"/>
+          </a:lnRef>
+          <a:fillRef idx="3">
+            <a:schemeClr val="accent1"/>
+          </a:fillRef>
+          <a:effectRef idx="2">
+            <a:schemeClr val="accent1"/>
+          </a:effectRef>
+          <a:fontRef idx="minor">
+            <a:schemeClr val="lt1"/>
+          </a:fontRef>
+        </p:style>
+        <p:txBody>
+          <a:bodyPr rtlCol="0" anchor="ctr"/>
+          <a:lstStyle/>
+          <a:p>
+            <a:pPr algn="ctr"/>
+          </a:p>
+        </p:txBody>
+      </p:sp>
+      <p:sp>
+        <p:nvSpPr>
+          <p:cNvPr id="4" name="Rounded Rectangle 3"/>
+          <p:cNvSpPr/>
+          <p:nvPr/>
+        </p:nvSpPr>
+        <p:spPr>
+          <a:xfrm>
+            <a:off x="9784080" y="201168"/>
+            <a:ext cx="1691640" cy="502920"/>
+          </a:xfrm>
+          <a:prstGeom prst="roundRect">
+            <a:avLst/>
+          </a:prstGeom>
+          <a:solidFill>
+            <a:srgbClr val="388BFD"/>
+          </a:solidFill>
+          <a:ln>
+            <a:noFill/>
+          </a:ln>
+        </p:spPr>
+        <p:style>
+          <a:lnRef idx="1">
+            <a:schemeClr val="accent1"/>
+          </a:lnRef>
+          <a:fillRef idx="3">
+            <a:schemeClr val="accent1"/>
+          </a:fillRef>
+          <a:effectRef idx="2">
+            <a:schemeClr val="accent1"/>
+          </a:effectRef>
+          <a:fontRef idx="minor">
+            <a:schemeClr val="lt1"/>
+          </a:fontRef>
+        </p:style>
+        <p:txBody>
+          <a:bodyPr rtlCol="0" anchor="ctr"/>
+          <a:lstStyle/>
+          <a:p>
+            <a:pPr algn="ctr"/>
+          </a:p>
+        </p:txBody>
+      </p:sp>
+      <p:sp>
+        <p:nvSpPr>
+          <p:cNvPr id="5" name="Rounded Rectangle 4"/>
+          <p:cNvSpPr/>
+          <p:nvPr/>
+        </p:nvSpPr>
+        <p:spPr>
+          <a:xfrm>
+            <a:off x="502920" y="1325880"/>
+            <a:ext cx="11155680" cy="5257800"/>
+          </a:xfrm>
+          <a:prstGeom prst="roundRect">
+            <a:avLst/>
+          </a:prstGeom>
+          <a:solidFill>
+            <a:srgbClr val="161B22"/>
+          </a:solidFill>
+          <a:ln w="12700">
+            <a:solidFill>
+              <a:srgbClr val="308C64"/>
+            </a:solidFill>
+          </a:ln>
+        </p:spPr>
+        <p:style>
+          <a:lnRef idx="1">
+            <a:schemeClr val="accent1"/>
+          </a:lnRef>
+          <a:fillRef idx="3">
+            <a:schemeClr val="accent1"/>
+          </a:fillRef>
+          <a:effectRef idx="2">
+            <a:schemeClr val="accent1"/>
+          </a:effectRef>
+          <a:fontRef idx="minor">
+            <a:schemeClr val="lt1"/>
+          </a:fontRef>
+        </p:style>
+        <p:txBody>
+          <a:bodyPr rtlCol="0" anchor="ctr"/>
+          <a:lstStyle/>
+          <a:p>
+            <a:pPr algn="ctr"/>
+          </a:p>
+        </p:txBody>
+      </p:sp>
+      <p:sp>
+        <p:nvSpPr>
+          <p:cNvPr id="6" name="TextBox 5"/>
           <p:cNvSpPr txBox="1"/>
           <p:nvPr/>
         </p:nvSpPr>
         <p:spPr>
           <a:xfrm>
-            <a:off x="685800" y="502920"/>
-            <a:ext cx="10789920" cy="1005840"/>
+            <a:off x="713232" y="246888"/>
+            <a:ext cx="9692640" cy="777240"/>
           </a:xfrm>
           <a:prstGeom prst="rect">
             <a:avLst/>
@@ -3636,11 +4158,11 @@
           <a:lstStyle/>
           <a:p>
             <a:pPr>
-              <a:defRPr sz="3400" b="1">
+              <a:defRPr sz="3000" b="1">
                 <a:solidFill>
                   <a:srgbClr val="FFFFFF"/>
                 </a:solidFill>
-                <a:latin typeface="Arial"/>
+                <a:latin typeface="Calibri"/>
               </a:defRPr>
             </a:pPr>
             <a:r>
@@ -3651,14 +4173,14 @@
       </p:sp>
       <p:sp>
         <p:nvSpPr>
-          <p:cNvPr id="3" name="TextBox 2"/>
+          <p:cNvPr id="7" name="TextBox 6"/>
           <p:cNvSpPr txBox="1"/>
           <p:nvPr/>
         </p:nvSpPr>
         <p:spPr>
           <a:xfrm>
-            <a:off x="685800" y="1645920"/>
-            <a:ext cx="10789920" cy="4892040"/>
+            <a:off x="804672" y="1627632"/>
+            <a:ext cx="10561320" cy="4681728"/>
           </a:xfrm>
           <a:prstGeom prst="rect">
             <a:avLst/>
@@ -3673,13 +4195,13 @@
           <a:p>
             <a:pPr>
               <a:spcAft>
-                <a:spcPts val="700"/>
-              </a:spcAft>
-              <a:defRPr sz="1700">
-                <a:solidFill>
-                  <a:srgbClr val="B4B9C3"/>
-                </a:solidFill>
-                <a:latin typeface="Arial"/>
+                <a:spcPts val="600"/>
+              </a:spcAft>
+              <a:defRPr sz="2200" b="1">
+                <a:solidFill>
+                  <a:srgbClr val="00E676"/>
+                </a:solidFill>
+                <a:latin typeface="Calibri"/>
               </a:defRPr>
             </a:pPr>
             <a:r>
@@ -3689,13 +4211,13 @@
           <a:p>
             <a:pPr>
               <a:spcAft>
-                <a:spcPts val="700"/>
-              </a:spcAft>
-              <a:defRPr sz="1700">
-                <a:solidFill>
-                  <a:srgbClr val="B4B9C3"/>
-                </a:solidFill>
-                <a:latin typeface="Arial"/>
+                <a:spcPts val="600"/>
+              </a:spcAft>
+              <a:defRPr sz="1600">
+                <a:solidFill>
+                  <a:srgbClr val="C9D1D9"/>
+                </a:solidFill>
+                <a:latin typeface="Calibri"/>
               </a:defRPr>
             </a:pPr>
             <a:r>
@@ -3705,13 +4227,13 @@
           <a:p>
             <a:pPr>
               <a:spcAft>
-                <a:spcPts val="700"/>
-              </a:spcAft>
-              <a:defRPr sz="1700">
-                <a:solidFill>
-                  <a:srgbClr val="B4B9C3"/>
-                </a:solidFill>
-                <a:latin typeface="Arial"/>
+                <a:spcPts val="600"/>
+              </a:spcAft>
+              <a:defRPr sz="1600">
+                <a:solidFill>
+                  <a:srgbClr val="C9D1D9"/>
+                </a:solidFill>
+                <a:latin typeface="Calibri"/>
               </a:defRPr>
             </a:pPr>
             <a:r>
@@ -3721,26 +4243,26 @@
           <a:p>
             <a:pPr>
               <a:spcAft>
-                <a:spcPts val="700"/>
-              </a:spcAft>
-              <a:defRPr sz="1700">
-                <a:solidFill>
-                  <a:srgbClr val="B4B9C3"/>
-                </a:solidFill>
-                <a:latin typeface="Arial"/>
-              </a:defRPr>
-            </a:pPr>
-          </a:p>
-          <a:p>
-            <a:pPr>
-              <a:spcAft>
-                <a:spcPts val="700"/>
-              </a:spcAft>
-              <a:defRPr sz="1700">
-                <a:solidFill>
-                  <a:srgbClr val="B4B9C3"/>
-                </a:solidFill>
-                <a:latin typeface="Arial"/>
+                <a:spcPts val="600"/>
+              </a:spcAft>
+              <a:defRPr sz="1600">
+                <a:solidFill>
+                  <a:srgbClr val="C9D1D9"/>
+                </a:solidFill>
+                <a:latin typeface="Calibri"/>
+              </a:defRPr>
+            </a:pPr>
+          </a:p>
+          <a:p>
+            <a:pPr>
+              <a:spcAft>
+                <a:spcPts val="600"/>
+              </a:spcAft>
+              <a:defRPr sz="2200" b="1">
+                <a:solidFill>
+                  <a:srgbClr val="00E676"/>
+                </a:solidFill>
+                <a:latin typeface="Calibri"/>
               </a:defRPr>
             </a:pPr>
             <a:r>
@@ -3750,13 +4272,13 @@
           <a:p>
             <a:pPr>
               <a:spcAft>
-                <a:spcPts val="700"/>
-              </a:spcAft>
-              <a:defRPr sz="1700">
-                <a:solidFill>
-                  <a:srgbClr val="B4B9C3"/>
-                </a:solidFill>
-                <a:latin typeface="Arial"/>
+                <a:spcPts val="600"/>
+              </a:spcAft>
+              <a:defRPr sz="1600">
+                <a:solidFill>
+                  <a:srgbClr val="C9D1D9"/>
+                </a:solidFill>
+                <a:latin typeface="Calibri"/>
               </a:defRPr>
             </a:pPr>
             <a:r>
@@ -3766,13 +4288,13 @@
           <a:p>
             <a:pPr>
               <a:spcAft>
-                <a:spcPts val="700"/>
-              </a:spcAft>
-              <a:defRPr sz="1700">
-                <a:solidFill>
-                  <a:srgbClr val="B4B9C3"/>
-                </a:solidFill>
-                <a:latin typeface="Arial"/>
+                <a:spcPts val="600"/>
+              </a:spcAft>
+              <a:defRPr sz="1600">
+                <a:solidFill>
+                  <a:srgbClr val="C9D1D9"/>
+                </a:solidFill>
+                <a:latin typeface="Calibri"/>
               </a:defRPr>
             </a:pPr>
             <a:r>
@@ -3809,14 +4331,188 @@
       <p:grpSpPr/>
       <p:sp>
         <p:nvSpPr>
-          <p:cNvPr id="2" name="TextBox 1"/>
+          <p:cNvPr id="2" name="Rectangle 1"/>
+          <p:cNvSpPr/>
+          <p:nvPr/>
+        </p:nvSpPr>
+        <p:spPr>
+          <a:xfrm>
+            <a:off x="0" y="0"/>
+            <a:ext cx="12191695" cy="1051560"/>
+          </a:xfrm>
+          <a:prstGeom prst="rect">
+            <a:avLst/>
+          </a:prstGeom>
+          <a:solidFill>
+            <a:srgbClr val="121821"/>
+          </a:solidFill>
+          <a:ln>
+            <a:noFill/>
+          </a:ln>
+        </p:spPr>
+        <p:style>
+          <a:lnRef idx="1">
+            <a:schemeClr val="accent1"/>
+          </a:lnRef>
+          <a:fillRef idx="3">
+            <a:schemeClr val="accent1"/>
+          </a:fillRef>
+          <a:effectRef idx="2">
+            <a:schemeClr val="accent1"/>
+          </a:effectRef>
+          <a:fontRef idx="minor">
+            <a:schemeClr val="lt1"/>
+          </a:fontRef>
+        </p:style>
+        <p:txBody>
+          <a:bodyPr rtlCol="0" anchor="ctr"/>
+          <a:lstStyle/>
+          <a:p>
+            <a:pPr algn="ctr"/>
+          </a:p>
+        </p:txBody>
+      </p:sp>
+      <p:sp>
+        <p:nvSpPr>
+          <p:cNvPr id="3" name="Rectangle 2"/>
+          <p:cNvSpPr/>
+          <p:nvPr/>
+        </p:nvSpPr>
+        <p:spPr>
+          <a:xfrm>
+            <a:off x="0" y="0"/>
+            <a:ext cx="12191695" cy="73152"/>
+          </a:xfrm>
+          <a:prstGeom prst="rect">
+            <a:avLst/>
+          </a:prstGeom>
+          <a:solidFill>
+            <a:srgbClr val="00E676"/>
+          </a:solidFill>
+          <a:ln>
+            <a:noFill/>
+          </a:ln>
+        </p:spPr>
+        <p:style>
+          <a:lnRef idx="1">
+            <a:schemeClr val="accent1"/>
+          </a:lnRef>
+          <a:fillRef idx="3">
+            <a:schemeClr val="accent1"/>
+          </a:fillRef>
+          <a:effectRef idx="2">
+            <a:schemeClr val="accent1"/>
+          </a:effectRef>
+          <a:fontRef idx="minor">
+            <a:schemeClr val="lt1"/>
+          </a:fontRef>
+        </p:style>
+        <p:txBody>
+          <a:bodyPr rtlCol="0" anchor="ctr"/>
+          <a:lstStyle/>
+          <a:p>
+            <a:pPr algn="ctr"/>
+          </a:p>
+        </p:txBody>
+      </p:sp>
+      <p:sp>
+        <p:nvSpPr>
+          <p:cNvPr id="4" name="Rounded Rectangle 3"/>
+          <p:cNvSpPr/>
+          <p:nvPr/>
+        </p:nvSpPr>
+        <p:spPr>
+          <a:xfrm>
+            <a:off x="9784080" y="201168"/>
+            <a:ext cx="1691640" cy="502920"/>
+          </a:xfrm>
+          <a:prstGeom prst="roundRect">
+            <a:avLst/>
+          </a:prstGeom>
+          <a:solidFill>
+            <a:srgbClr val="388BFD"/>
+          </a:solidFill>
+          <a:ln>
+            <a:noFill/>
+          </a:ln>
+        </p:spPr>
+        <p:style>
+          <a:lnRef idx="1">
+            <a:schemeClr val="accent1"/>
+          </a:lnRef>
+          <a:fillRef idx="3">
+            <a:schemeClr val="accent1"/>
+          </a:fillRef>
+          <a:effectRef idx="2">
+            <a:schemeClr val="accent1"/>
+          </a:effectRef>
+          <a:fontRef idx="minor">
+            <a:schemeClr val="lt1"/>
+          </a:fontRef>
+        </p:style>
+        <p:txBody>
+          <a:bodyPr rtlCol="0" anchor="ctr"/>
+          <a:lstStyle/>
+          <a:p>
+            <a:pPr algn="ctr"/>
+          </a:p>
+        </p:txBody>
+      </p:sp>
+      <p:sp>
+        <p:nvSpPr>
+          <p:cNvPr id="5" name="Rounded Rectangle 4"/>
+          <p:cNvSpPr/>
+          <p:nvPr/>
+        </p:nvSpPr>
+        <p:spPr>
+          <a:xfrm>
+            <a:off x="502920" y="1325880"/>
+            <a:ext cx="11155680" cy="5257800"/>
+          </a:xfrm>
+          <a:prstGeom prst="roundRect">
+            <a:avLst/>
+          </a:prstGeom>
+          <a:solidFill>
+            <a:srgbClr val="161B22"/>
+          </a:solidFill>
+          <a:ln w="12700">
+            <a:solidFill>
+              <a:srgbClr val="308C64"/>
+            </a:solidFill>
+          </a:ln>
+        </p:spPr>
+        <p:style>
+          <a:lnRef idx="1">
+            <a:schemeClr val="accent1"/>
+          </a:lnRef>
+          <a:fillRef idx="3">
+            <a:schemeClr val="accent1"/>
+          </a:fillRef>
+          <a:effectRef idx="2">
+            <a:schemeClr val="accent1"/>
+          </a:effectRef>
+          <a:fontRef idx="minor">
+            <a:schemeClr val="lt1"/>
+          </a:fontRef>
+        </p:style>
+        <p:txBody>
+          <a:bodyPr rtlCol="0" anchor="ctr"/>
+          <a:lstStyle/>
+          <a:p>
+            <a:pPr algn="ctr"/>
+          </a:p>
+        </p:txBody>
+      </p:sp>
+      <p:sp>
+        <p:nvSpPr>
+          <p:cNvPr id="6" name="TextBox 5"/>
           <p:cNvSpPr txBox="1"/>
           <p:nvPr/>
         </p:nvSpPr>
         <p:spPr>
           <a:xfrm>
-            <a:off x="685800" y="502920"/>
-            <a:ext cx="10789920" cy="1005840"/>
+            <a:off x="713232" y="246888"/>
+            <a:ext cx="9692640" cy="777240"/>
           </a:xfrm>
           <a:prstGeom prst="rect">
             <a:avLst/>
@@ -3830,11 +4526,11 @@
           <a:lstStyle/>
           <a:p>
             <a:pPr>
-              <a:defRPr sz="3400" b="1">
+              <a:defRPr sz="3000" b="1">
                 <a:solidFill>
                   <a:srgbClr val="FFFFFF"/>
                 </a:solidFill>
-                <a:latin typeface="Arial"/>
+                <a:latin typeface="Calibri"/>
               </a:defRPr>
             </a:pPr>
             <a:r>
@@ -3845,14 +4541,14 @@
       </p:sp>
       <p:sp>
         <p:nvSpPr>
-          <p:cNvPr id="3" name="TextBox 2"/>
+          <p:cNvPr id="7" name="TextBox 6"/>
           <p:cNvSpPr txBox="1"/>
           <p:nvPr/>
         </p:nvSpPr>
         <p:spPr>
           <a:xfrm>
-            <a:off x="685800" y="1645920"/>
-            <a:ext cx="10789920" cy="4892040"/>
+            <a:off x="804672" y="1627632"/>
+            <a:ext cx="10561320" cy="4681728"/>
           </a:xfrm>
           <a:prstGeom prst="rect">
             <a:avLst/>
@@ -3867,13 +4563,13 @@
           <a:p>
             <a:pPr>
               <a:spcAft>
-                <a:spcPts val="700"/>
-              </a:spcAft>
-              <a:defRPr sz="1700">
-                <a:solidFill>
-                  <a:srgbClr val="B4B9C3"/>
-                </a:solidFill>
-                <a:latin typeface="Arial"/>
+                <a:spcPts val="600"/>
+              </a:spcAft>
+              <a:defRPr sz="1600">
+                <a:solidFill>
+                  <a:srgbClr val="C9D1D9"/>
+                </a:solidFill>
+                <a:latin typeface="Calibri"/>
               </a:defRPr>
             </a:pPr>
             <a:r>
@@ -3883,13 +4579,13 @@
           <a:p>
             <a:pPr>
               <a:spcAft>
-                <a:spcPts val="700"/>
-              </a:spcAft>
-              <a:defRPr sz="1700">
-                <a:solidFill>
-                  <a:srgbClr val="B4B9C3"/>
-                </a:solidFill>
-                <a:latin typeface="Arial"/>
+                <a:spcPts val="600"/>
+              </a:spcAft>
+              <a:defRPr sz="1600">
+                <a:solidFill>
+                  <a:srgbClr val="C9D1D9"/>
+                </a:solidFill>
+                <a:latin typeface="Calibri"/>
               </a:defRPr>
             </a:pPr>
             <a:r>
@@ -3899,13 +4595,13 @@
           <a:p>
             <a:pPr>
               <a:spcAft>
-                <a:spcPts val="700"/>
-              </a:spcAft>
-              <a:defRPr sz="2300" b="1">
+                <a:spcPts val="600"/>
+              </a:spcAft>
+              <a:defRPr sz="2200" b="1">
                 <a:solidFill>
                   <a:srgbClr val="00E676"/>
                 </a:solidFill>
-                <a:latin typeface="Arial"/>
+                <a:latin typeface="Calibri"/>
               </a:defRPr>
             </a:pPr>
             <a:r>
@@ -3915,26 +4611,26 @@
           <a:p>
             <a:pPr>
               <a:spcAft>
-                <a:spcPts val="700"/>
-              </a:spcAft>
-              <a:defRPr sz="1700">
-                <a:solidFill>
-                  <a:srgbClr val="B4B9C3"/>
-                </a:solidFill>
-                <a:latin typeface="Arial"/>
-              </a:defRPr>
-            </a:pPr>
-          </a:p>
-          <a:p>
-            <a:pPr>
-              <a:spcAft>
-                <a:spcPts val="700"/>
-              </a:spcAft>
-              <a:defRPr sz="1700">
-                <a:solidFill>
-                  <a:srgbClr val="B4B9C3"/>
-                </a:solidFill>
-                <a:latin typeface="Arial"/>
+                <a:spcPts val="600"/>
+              </a:spcAft>
+              <a:defRPr sz="1600">
+                <a:solidFill>
+                  <a:srgbClr val="C9D1D9"/>
+                </a:solidFill>
+                <a:latin typeface="Calibri"/>
+              </a:defRPr>
+            </a:pPr>
+          </a:p>
+          <a:p>
+            <a:pPr>
+              <a:spcAft>
+                <a:spcPts val="600"/>
+              </a:spcAft>
+              <a:defRPr sz="1600">
+                <a:solidFill>
+                  <a:srgbClr val="C9D1D9"/>
+                </a:solidFill>
+                <a:latin typeface="Calibri"/>
               </a:defRPr>
             </a:pPr>
             <a:r>
@@ -3944,13 +4640,13 @@
           <a:p>
             <a:pPr>
               <a:spcAft>
-                <a:spcPts val="700"/>
-              </a:spcAft>
-              <a:defRPr sz="2300" b="1">
+                <a:spcPts val="600"/>
+              </a:spcAft>
+              <a:defRPr sz="2200" b="1">
                 <a:solidFill>
                   <a:srgbClr val="00E676"/>
                 </a:solidFill>
-                <a:latin typeface="Arial"/>
+                <a:latin typeface="Calibri"/>
               </a:defRPr>
             </a:pPr>
             <a:r>
@@ -3960,13 +4656,13 @@
           <a:p>
             <a:pPr>
               <a:spcAft>
-                <a:spcPts val="700"/>
-              </a:spcAft>
-              <a:defRPr sz="1700">
-                <a:solidFill>
-                  <a:srgbClr val="B4B9C3"/>
-                </a:solidFill>
-                <a:latin typeface="Arial"/>
+                <a:spcPts val="600"/>
+              </a:spcAft>
+              <a:defRPr sz="1600">
+                <a:solidFill>
+                  <a:srgbClr val="C9D1D9"/>
+                </a:solidFill>
+                <a:latin typeface="Calibri"/>
               </a:defRPr>
             </a:pPr>
             <a:r>
@@ -3976,13 +4672,13 @@
           <a:p>
             <a:pPr>
               <a:spcAft>
-                <a:spcPts val="700"/>
-              </a:spcAft>
-              <a:defRPr sz="2300" b="1">
+                <a:spcPts val="600"/>
+              </a:spcAft>
+              <a:defRPr sz="2200" b="1">
                 <a:solidFill>
                   <a:srgbClr val="00E676"/>
                 </a:solidFill>
-                <a:latin typeface="Arial"/>
+                <a:latin typeface="Calibri"/>
               </a:defRPr>
             </a:pPr>
             <a:r>
@@ -4019,14 +4715,188 @@
       <p:grpSpPr/>
       <p:sp>
         <p:nvSpPr>
-          <p:cNvPr id="2" name="TextBox 1"/>
+          <p:cNvPr id="2" name="Rectangle 1"/>
+          <p:cNvSpPr/>
+          <p:nvPr/>
+        </p:nvSpPr>
+        <p:spPr>
+          <a:xfrm>
+            <a:off x="0" y="0"/>
+            <a:ext cx="12191695" cy="1051560"/>
+          </a:xfrm>
+          <a:prstGeom prst="rect">
+            <a:avLst/>
+          </a:prstGeom>
+          <a:solidFill>
+            <a:srgbClr val="121821"/>
+          </a:solidFill>
+          <a:ln>
+            <a:noFill/>
+          </a:ln>
+        </p:spPr>
+        <p:style>
+          <a:lnRef idx="1">
+            <a:schemeClr val="accent1"/>
+          </a:lnRef>
+          <a:fillRef idx="3">
+            <a:schemeClr val="accent1"/>
+          </a:fillRef>
+          <a:effectRef idx="2">
+            <a:schemeClr val="accent1"/>
+          </a:effectRef>
+          <a:fontRef idx="minor">
+            <a:schemeClr val="lt1"/>
+          </a:fontRef>
+        </p:style>
+        <p:txBody>
+          <a:bodyPr rtlCol="0" anchor="ctr"/>
+          <a:lstStyle/>
+          <a:p>
+            <a:pPr algn="ctr"/>
+          </a:p>
+        </p:txBody>
+      </p:sp>
+      <p:sp>
+        <p:nvSpPr>
+          <p:cNvPr id="3" name="Rectangle 2"/>
+          <p:cNvSpPr/>
+          <p:nvPr/>
+        </p:nvSpPr>
+        <p:spPr>
+          <a:xfrm>
+            <a:off x="0" y="0"/>
+            <a:ext cx="12191695" cy="73152"/>
+          </a:xfrm>
+          <a:prstGeom prst="rect">
+            <a:avLst/>
+          </a:prstGeom>
+          <a:solidFill>
+            <a:srgbClr val="00E676"/>
+          </a:solidFill>
+          <a:ln>
+            <a:noFill/>
+          </a:ln>
+        </p:spPr>
+        <p:style>
+          <a:lnRef idx="1">
+            <a:schemeClr val="accent1"/>
+          </a:lnRef>
+          <a:fillRef idx="3">
+            <a:schemeClr val="accent1"/>
+          </a:fillRef>
+          <a:effectRef idx="2">
+            <a:schemeClr val="accent1"/>
+          </a:effectRef>
+          <a:fontRef idx="minor">
+            <a:schemeClr val="lt1"/>
+          </a:fontRef>
+        </p:style>
+        <p:txBody>
+          <a:bodyPr rtlCol="0" anchor="ctr"/>
+          <a:lstStyle/>
+          <a:p>
+            <a:pPr algn="ctr"/>
+          </a:p>
+        </p:txBody>
+      </p:sp>
+      <p:sp>
+        <p:nvSpPr>
+          <p:cNvPr id="4" name="Rounded Rectangle 3"/>
+          <p:cNvSpPr/>
+          <p:nvPr/>
+        </p:nvSpPr>
+        <p:spPr>
+          <a:xfrm>
+            <a:off x="9784080" y="201168"/>
+            <a:ext cx="1691640" cy="502920"/>
+          </a:xfrm>
+          <a:prstGeom prst="roundRect">
+            <a:avLst/>
+          </a:prstGeom>
+          <a:solidFill>
+            <a:srgbClr val="388BFD"/>
+          </a:solidFill>
+          <a:ln>
+            <a:noFill/>
+          </a:ln>
+        </p:spPr>
+        <p:style>
+          <a:lnRef idx="1">
+            <a:schemeClr val="accent1"/>
+          </a:lnRef>
+          <a:fillRef idx="3">
+            <a:schemeClr val="accent1"/>
+          </a:fillRef>
+          <a:effectRef idx="2">
+            <a:schemeClr val="accent1"/>
+          </a:effectRef>
+          <a:fontRef idx="minor">
+            <a:schemeClr val="lt1"/>
+          </a:fontRef>
+        </p:style>
+        <p:txBody>
+          <a:bodyPr rtlCol="0" anchor="ctr"/>
+          <a:lstStyle/>
+          <a:p>
+            <a:pPr algn="ctr"/>
+          </a:p>
+        </p:txBody>
+      </p:sp>
+      <p:sp>
+        <p:nvSpPr>
+          <p:cNvPr id="5" name="Rounded Rectangle 4"/>
+          <p:cNvSpPr/>
+          <p:nvPr/>
+        </p:nvSpPr>
+        <p:spPr>
+          <a:xfrm>
+            <a:off x="502920" y="1325880"/>
+            <a:ext cx="11155680" cy="5257800"/>
+          </a:xfrm>
+          <a:prstGeom prst="roundRect">
+            <a:avLst/>
+          </a:prstGeom>
+          <a:solidFill>
+            <a:srgbClr val="161B22"/>
+          </a:solidFill>
+          <a:ln w="12700">
+            <a:solidFill>
+              <a:srgbClr val="308C64"/>
+            </a:solidFill>
+          </a:ln>
+        </p:spPr>
+        <p:style>
+          <a:lnRef idx="1">
+            <a:schemeClr val="accent1"/>
+          </a:lnRef>
+          <a:fillRef idx="3">
+            <a:schemeClr val="accent1"/>
+          </a:fillRef>
+          <a:effectRef idx="2">
+            <a:schemeClr val="accent1"/>
+          </a:effectRef>
+          <a:fontRef idx="minor">
+            <a:schemeClr val="lt1"/>
+          </a:fontRef>
+        </p:style>
+        <p:txBody>
+          <a:bodyPr rtlCol="0" anchor="ctr"/>
+          <a:lstStyle/>
+          <a:p>
+            <a:pPr algn="ctr"/>
+          </a:p>
+        </p:txBody>
+      </p:sp>
+      <p:sp>
+        <p:nvSpPr>
+          <p:cNvPr id="6" name="TextBox 5"/>
           <p:cNvSpPr txBox="1"/>
           <p:nvPr/>
         </p:nvSpPr>
         <p:spPr>
           <a:xfrm>
-            <a:off x="685800" y="502920"/>
-            <a:ext cx="10789920" cy="1005840"/>
+            <a:off x="713232" y="246888"/>
+            <a:ext cx="9692640" cy="777240"/>
           </a:xfrm>
           <a:prstGeom prst="rect">
             <a:avLst/>
@@ -4040,11 +4910,11 @@
           <a:lstStyle/>
           <a:p>
             <a:pPr>
-              <a:defRPr sz="3400" b="1">
+              <a:defRPr sz="3000" b="1">
                 <a:solidFill>
                   <a:srgbClr val="FFFFFF"/>
                 </a:solidFill>
-                <a:latin typeface="Arial"/>
+                <a:latin typeface="Calibri"/>
               </a:defRPr>
             </a:pPr>
             <a:r>
@@ -4055,14 +4925,14 @@
       </p:sp>
       <p:sp>
         <p:nvSpPr>
-          <p:cNvPr id="3" name="TextBox 2"/>
+          <p:cNvPr id="7" name="TextBox 6"/>
           <p:cNvSpPr txBox="1"/>
           <p:nvPr/>
         </p:nvSpPr>
         <p:spPr>
           <a:xfrm>
-            <a:off x="685800" y="1645920"/>
-            <a:ext cx="10789920" cy="4892040"/>
+            <a:off x="804672" y="1627632"/>
+            <a:ext cx="10561320" cy="4681728"/>
           </a:xfrm>
           <a:prstGeom prst="rect">
             <a:avLst/>
@@ -4077,13 +4947,13 @@
           <a:p>
             <a:pPr>
               <a:spcAft>
-                <a:spcPts val="700"/>
-              </a:spcAft>
-              <a:defRPr sz="1700">
-                <a:solidFill>
-                  <a:srgbClr val="B4B9C3"/>
-                </a:solidFill>
-                <a:latin typeface="Arial"/>
+                <a:spcPts val="600"/>
+              </a:spcAft>
+              <a:defRPr sz="1600">
+                <a:solidFill>
+                  <a:srgbClr val="C9D1D9"/>
+                </a:solidFill>
+                <a:latin typeface="Calibri"/>
               </a:defRPr>
             </a:pPr>
             <a:r>
@@ -4093,26 +4963,26 @@
           <a:p>
             <a:pPr>
               <a:spcAft>
-                <a:spcPts val="700"/>
-              </a:spcAft>
-              <a:defRPr sz="1700">
-                <a:solidFill>
-                  <a:srgbClr val="B4B9C3"/>
-                </a:solidFill>
-                <a:latin typeface="Arial"/>
-              </a:defRPr>
-            </a:pPr>
-          </a:p>
-          <a:p>
-            <a:pPr>
-              <a:spcAft>
-                <a:spcPts val="700"/>
-              </a:spcAft>
-              <a:defRPr sz="1700">
-                <a:solidFill>
-                  <a:srgbClr val="B4B9C3"/>
-                </a:solidFill>
-                <a:latin typeface="Arial"/>
+                <a:spcPts val="600"/>
+              </a:spcAft>
+              <a:defRPr sz="1600">
+                <a:solidFill>
+                  <a:srgbClr val="C9D1D9"/>
+                </a:solidFill>
+                <a:latin typeface="Calibri"/>
+              </a:defRPr>
+            </a:pPr>
+          </a:p>
+          <a:p>
+            <a:pPr>
+              <a:spcAft>
+                <a:spcPts val="600"/>
+              </a:spcAft>
+              <a:defRPr sz="1600">
+                <a:solidFill>
+                  <a:srgbClr val="C9D1D9"/>
+                </a:solidFill>
+                <a:latin typeface="Calibri"/>
               </a:defRPr>
             </a:pPr>
             <a:r>
@@ -4122,13 +4992,13 @@
           <a:p>
             <a:pPr>
               <a:spcAft>
-                <a:spcPts val="700"/>
-              </a:spcAft>
-              <a:defRPr sz="1700">
-                <a:solidFill>
-                  <a:srgbClr val="B4B9C3"/>
-                </a:solidFill>
-                <a:latin typeface="Arial"/>
+                <a:spcPts val="600"/>
+              </a:spcAft>
+              <a:defRPr sz="1600">
+                <a:solidFill>
+                  <a:srgbClr val="C9D1D9"/>
+                </a:solidFill>
+                <a:latin typeface="Calibri"/>
               </a:defRPr>
             </a:pPr>
             <a:r>
@@ -4138,13 +5008,13 @@
           <a:p>
             <a:pPr>
               <a:spcAft>
-                <a:spcPts val="700"/>
-              </a:spcAft>
-              <a:defRPr sz="1700">
-                <a:solidFill>
-                  <a:srgbClr val="B4B9C3"/>
-                </a:solidFill>
-                <a:latin typeface="Arial"/>
+                <a:spcPts val="600"/>
+              </a:spcAft>
+              <a:defRPr sz="1600">
+                <a:solidFill>
+                  <a:srgbClr val="C9D1D9"/>
+                </a:solidFill>
+                <a:latin typeface="Calibri"/>
               </a:defRPr>
             </a:pPr>
             <a:r>
@@ -4154,26 +5024,26 @@
           <a:p>
             <a:pPr>
               <a:spcAft>
-                <a:spcPts val="700"/>
-              </a:spcAft>
-              <a:defRPr sz="1700">
-                <a:solidFill>
-                  <a:srgbClr val="B4B9C3"/>
-                </a:solidFill>
-                <a:latin typeface="Arial"/>
-              </a:defRPr>
-            </a:pPr>
-          </a:p>
-          <a:p>
-            <a:pPr>
-              <a:spcAft>
-                <a:spcPts val="700"/>
-              </a:spcAft>
-              <a:defRPr sz="1700">
-                <a:solidFill>
-                  <a:srgbClr val="B4B9C3"/>
-                </a:solidFill>
-                <a:latin typeface="Arial"/>
+                <a:spcPts val="600"/>
+              </a:spcAft>
+              <a:defRPr sz="1600">
+                <a:solidFill>
+                  <a:srgbClr val="C9D1D9"/>
+                </a:solidFill>
+                <a:latin typeface="Calibri"/>
+              </a:defRPr>
+            </a:pPr>
+          </a:p>
+          <a:p>
+            <a:pPr>
+              <a:spcAft>
+                <a:spcPts val="600"/>
+              </a:spcAft>
+              <a:defRPr sz="1600">
+                <a:solidFill>
+                  <a:srgbClr val="C9D1D9"/>
+                </a:solidFill>
+                <a:latin typeface="Calibri"/>
               </a:defRPr>
             </a:pPr>
             <a:r>
@@ -4183,13 +5053,13 @@
           <a:p>
             <a:pPr>
               <a:spcAft>
-                <a:spcPts val="700"/>
-              </a:spcAft>
-              <a:defRPr sz="1700">
-                <a:solidFill>
-                  <a:srgbClr val="B4B9C3"/>
-                </a:solidFill>
-                <a:latin typeface="Arial"/>
+                <a:spcPts val="600"/>
+              </a:spcAft>
+              <a:defRPr sz="1600">
+                <a:solidFill>
+                  <a:srgbClr val="C9D1D9"/>
+                </a:solidFill>
+                <a:latin typeface="Calibri"/>
               </a:defRPr>
             </a:pPr>
             <a:r>
@@ -4199,13 +5069,13 @@
           <a:p>
             <a:pPr>
               <a:spcAft>
-                <a:spcPts val="700"/>
-              </a:spcAft>
-              <a:defRPr sz="1700">
-                <a:solidFill>
-                  <a:srgbClr val="B4B9C3"/>
-                </a:solidFill>
-                <a:latin typeface="Arial"/>
+                <a:spcPts val="600"/>
+              </a:spcAft>
+              <a:defRPr sz="1600">
+                <a:solidFill>
+                  <a:srgbClr val="C9D1D9"/>
+                </a:solidFill>
+                <a:latin typeface="Calibri"/>
               </a:defRPr>
             </a:pPr>
             <a:r>
@@ -4215,26 +5085,26 @@
           <a:p>
             <a:pPr>
               <a:spcAft>
-                <a:spcPts val="700"/>
-              </a:spcAft>
-              <a:defRPr sz="1700">
-                <a:solidFill>
-                  <a:srgbClr val="B4B9C3"/>
-                </a:solidFill>
-                <a:latin typeface="Arial"/>
-              </a:defRPr>
-            </a:pPr>
-          </a:p>
-          <a:p>
-            <a:pPr>
-              <a:spcAft>
-                <a:spcPts val="700"/>
-              </a:spcAft>
-              <a:defRPr sz="1700">
-                <a:solidFill>
-                  <a:srgbClr val="B4B9C3"/>
-                </a:solidFill>
-                <a:latin typeface="Arial"/>
+                <a:spcPts val="600"/>
+              </a:spcAft>
+              <a:defRPr sz="1600">
+                <a:solidFill>
+                  <a:srgbClr val="C9D1D9"/>
+                </a:solidFill>
+                <a:latin typeface="Calibri"/>
+              </a:defRPr>
+            </a:pPr>
+          </a:p>
+          <a:p>
+            <a:pPr>
+              <a:spcAft>
+                <a:spcPts val="600"/>
+              </a:spcAft>
+              <a:defRPr sz="1600">
+                <a:solidFill>
+                  <a:srgbClr val="C9D1D9"/>
+                </a:solidFill>
+                <a:latin typeface="Calibri"/>
               </a:defRPr>
             </a:pPr>
             <a:r>
@@ -4244,13 +5114,13 @@
           <a:p>
             <a:pPr>
               <a:spcAft>
-                <a:spcPts val="700"/>
-              </a:spcAft>
-              <a:defRPr sz="1700">
-                <a:solidFill>
-                  <a:srgbClr val="B4B9C3"/>
-                </a:solidFill>
-                <a:latin typeface="Arial"/>
+                <a:spcPts val="600"/>
+              </a:spcAft>
+              <a:defRPr sz="1600">
+                <a:solidFill>
+                  <a:srgbClr val="C9D1D9"/>
+                </a:solidFill>
+                <a:latin typeface="Calibri"/>
               </a:defRPr>
             </a:pPr>
             <a:r>
@@ -4287,14 +5157,188 @@
       <p:grpSpPr/>
       <p:sp>
         <p:nvSpPr>
-          <p:cNvPr id="2" name="TextBox 1"/>
+          <p:cNvPr id="2" name="Rectangle 1"/>
+          <p:cNvSpPr/>
+          <p:nvPr/>
+        </p:nvSpPr>
+        <p:spPr>
+          <a:xfrm>
+            <a:off x="0" y="0"/>
+            <a:ext cx="12191695" cy="1051560"/>
+          </a:xfrm>
+          <a:prstGeom prst="rect">
+            <a:avLst/>
+          </a:prstGeom>
+          <a:solidFill>
+            <a:srgbClr val="121821"/>
+          </a:solidFill>
+          <a:ln>
+            <a:noFill/>
+          </a:ln>
+        </p:spPr>
+        <p:style>
+          <a:lnRef idx="1">
+            <a:schemeClr val="accent1"/>
+          </a:lnRef>
+          <a:fillRef idx="3">
+            <a:schemeClr val="accent1"/>
+          </a:fillRef>
+          <a:effectRef idx="2">
+            <a:schemeClr val="accent1"/>
+          </a:effectRef>
+          <a:fontRef idx="minor">
+            <a:schemeClr val="lt1"/>
+          </a:fontRef>
+        </p:style>
+        <p:txBody>
+          <a:bodyPr rtlCol="0" anchor="ctr"/>
+          <a:lstStyle/>
+          <a:p>
+            <a:pPr algn="ctr"/>
+          </a:p>
+        </p:txBody>
+      </p:sp>
+      <p:sp>
+        <p:nvSpPr>
+          <p:cNvPr id="3" name="Rectangle 2"/>
+          <p:cNvSpPr/>
+          <p:nvPr/>
+        </p:nvSpPr>
+        <p:spPr>
+          <a:xfrm>
+            <a:off x="0" y="0"/>
+            <a:ext cx="12191695" cy="73152"/>
+          </a:xfrm>
+          <a:prstGeom prst="rect">
+            <a:avLst/>
+          </a:prstGeom>
+          <a:solidFill>
+            <a:srgbClr val="00E676"/>
+          </a:solidFill>
+          <a:ln>
+            <a:noFill/>
+          </a:ln>
+        </p:spPr>
+        <p:style>
+          <a:lnRef idx="1">
+            <a:schemeClr val="accent1"/>
+          </a:lnRef>
+          <a:fillRef idx="3">
+            <a:schemeClr val="accent1"/>
+          </a:fillRef>
+          <a:effectRef idx="2">
+            <a:schemeClr val="accent1"/>
+          </a:effectRef>
+          <a:fontRef idx="minor">
+            <a:schemeClr val="lt1"/>
+          </a:fontRef>
+        </p:style>
+        <p:txBody>
+          <a:bodyPr rtlCol="0" anchor="ctr"/>
+          <a:lstStyle/>
+          <a:p>
+            <a:pPr algn="ctr"/>
+          </a:p>
+        </p:txBody>
+      </p:sp>
+      <p:sp>
+        <p:nvSpPr>
+          <p:cNvPr id="4" name="Rounded Rectangle 3"/>
+          <p:cNvSpPr/>
+          <p:nvPr/>
+        </p:nvSpPr>
+        <p:spPr>
+          <a:xfrm>
+            <a:off x="9784080" y="201168"/>
+            <a:ext cx="1691640" cy="502920"/>
+          </a:xfrm>
+          <a:prstGeom prst="roundRect">
+            <a:avLst/>
+          </a:prstGeom>
+          <a:solidFill>
+            <a:srgbClr val="388BFD"/>
+          </a:solidFill>
+          <a:ln>
+            <a:noFill/>
+          </a:ln>
+        </p:spPr>
+        <p:style>
+          <a:lnRef idx="1">
+            <a:schemeClr val="accent1"/>
+          </a:lnRef>
+          <a:fillRef idx="3">
+            <a:schemeClr val="accent1"/>
+          </a:fillRef>
+          <a:effectRef idx="2">
+            <a:schemeClr val="accent1"/>
+          </a:effectRef>
+          <a:fontRef idx="minor">
+            <a:schemeClr val="lt1"/>
+          </a:fontRef>
+        </p:style>
+        <p:txBody>
+          <a:bodyPr rtlCol="0" anchor="ctr"/>
+          <a:lstStyle/>
+          <a:p>
+            <a:pPr algn="ctr"/>
+          </a:p>
+        </p:txBody>
+      </p:sp>
+      <p:sp>
+        <p:nvSpPr>
+          <p:cNvPr id="5" name="Rounded Rectangle 4"/>
+          <p:cNvSpPr/>
+          <p:nvPr/>
+        </p:nvSpPr>
+        <p:spPr>
+          <a:xfrm>
+            <a:off x="502920" y="1325880"/>
+            <a:ext cx="11155680" cy="5257800"/>
+          </a:xfrm>
+          <a:prstGeom prst="roundRect">
+            <a:avLst/>
+          </a:prstGeom>
+          <a:solidFill>
+            <a:srgbClr val="161B22"/>
+          </a:solidFill>
+          <a:ln w="12700">
+            <a:solidFill>
+              <a:srgbClr val="308C64"/>
+            </a:solidFill>
+          </a:ln>
+        </p:spPr>
+        <p:style>
+          <a:lnRef idx="1">
+            <a:schemeClr val="accent1"/>
+          </a:lnRef>
+          <a:fillRef idx="3">
+            <a:schemeClr val="accent1"/>
+          </a:fillRef>
+          <a:effectRef idx="2">
+            <a:schemeClr val="accent1"/>
+          </a:effectRef>
+          <a:fontRef idx="minor">
+            <a:schemeClr val="lt1"/>
+          </a:fontRef>
+        </p:style>
+        <p:txBody>
+          <a:bodyPr rtlCol="0" anchor="ctr"/>
+          <a:lstStyle/>
+          <a:p>
+            <a:pPr algn="ctr"/>
+          </a:p>
+        </p:txBody>
+      </p:sp>
+      <p:sp>
+        <p:nvSpPr>
+          <p:cNvPr id="6" name="TextBox 5"/>
           <p:cNvSpPr txBox="1"/>
           <p:nvPr/>
         </p:nvSpPr>
         <p:spPr>
           <a:xfrm>
-            <a:off x="685800" y="502920"/>
-            <a:ext cx="10789920" cy="1005840"/>
+            <a:off x="713232" y="246888"/>
+            <a:ext cx="9692640" cy="777240"/>
           </a:xfrm>
           <a:prstGeom prst="rect">
             <a:avLst/>
@@ -4308,11 +5352,11 @@
           <a:lstStyle/>
           <a:p>
             <a:pPr>
-              <a:defRPr sz="3400" b="1">
+              <a:defRPr sz="3000" b="1">
                 <a:solidFill>
                   <a:srgbClr val="FFFFFF"/>
                 </a:solidFill>
-                <a:latin typeface="Arial"/>
+                <a:latin typeface="Calibri"/>
               </a:defRPr>
             </a:pPr>
             <a:r>
@@ -4323,14 +5367,14 @@
       </p:sp>
       <p:sp>
         <p:nvSpPr>
-          <p:cNvPr id="3" name="TextBox 2"/>
+          <p:cNvPr id="7" name="TextBox 6"/>
           <p:cNvSpPr txBox="1"/>
           <p:nvPr/>
         </p:nvSpPr>
         <p:spPr>
           <a:xfrm>
-            <a:off x="685800" y="1645920"/>
-            <a:ext cx="10789920" cy="4892040"/>
+            <a:off x="804672" y="1627632"/>
+            <a:ext cx="10561320" cy="4681728"/>
           </a:xfrm>
           <a:prstGeom prst="rect">
             <a:avLst/>
@@ -4345,13 +5389,13 @@
           <a:p>
             <a:pPr>
               <a:spcAft>
-                <a:spcPts val="700"/>
-              </a:spcAft>
-              <a:defRPr sz="1700">
-                <a:solidFill>
-                  <a:srgbClr val="B4B9C3"/>
-                </a:solidFill>
-                <a:latin typeface="Arial"/>
+                <a:spcPts val="600"/>
+              </a:spcAft>
+              <a:defRPr sz="1600">
+                <a:solidFill>
+                  <a:srgbClr val="C9D1D9"/>
+                </a:solidFill>
+                <a:latin typeface="Calibri"/>
               </a:defRPr>
             </a:pPr>
             <a:r>
@@ -4361,26 +5405,26 @@
           <a:p>
             <a:pPr>
               <a:spcAft>
-                <a:spcPts val="700"/>
-              </a:spcAft>
-              <a:defRPr sz="1700">
-                <a:solidFill>
-                  <a:srgbClr val="B4B9C3"/>
-                </a:solidFill>
-                <a:latin typeface="Arial"/>
-              </a:defRPr>
-            </a:pPr>
-          </a:p>
-          <a:p>
-            <a:pPr>
-              <a:spcAft>
-                <a:spcPts val="700"/>
-              </a:spcAft>
-              <a:defRPr sz="2300" b="1">
+                <a:spcPts val="600"/>
+              </a:spcAft>
+              <a:defRPr sz="1600">
+                <a:solidFill>
+                  <a:srgbClr val="C9D1D9"/>
+                </a:solidFill>
+                <a:latin typeface="Calibri"/>
+              </a:defRPr>
+            </a:pPr>
+          </a:p>
+          <a:p>
+            <a:pPr>
+              <a:spcAft>
+                <a:spcPts val="600"/>
+              </a:spcAft>
+              <a:defRPr sz="2200" b="1">
                 <a:solidFill>
                   <a:srgbClr val="00E676"/>
                 </a:solidFill>
-                <a:latin typeface="Arial"/>
+                <a:latin typeface="Calibri"/>
               </a:defRPr>
             </a:pPr>
             <a:r>
@@ -4390,13 +5434,13 @@
           <a:p>
             <a:pPr>
               <a:spcAft>
-                <a:spcPts val="700"/>
-              </a:spcAft>
-              <a:defRPr sz="1700">
-                <a:solidFill>
-                  <a:srgbClr val="B4B9C3"/>
-                </a:solidFill>
-                <a:latin typeface="Arial"/>
+                <a:spcPts val="600"/>
+              </a:spcAft>
+              <a:defRPr sz="1600">
+                <a:solidFill>
+                  <a:srgbClr val="C9D1D9"/>
+                </a:solidFill>
+                <a:latin typeface="Calibri"/>
               </a:defRPr>
             </a:pPr>
             <a:r>
@@ -4406,13 +5450,13 @@
           <a:p>
             <a:pPr>
               <a:spcAft>
-                <a:spcPts val="700"/>
-              </a:spcAft>
-              <a:defRPr sz="1700">
-                <a:solidFill>
-                  <a:srgbClr val="B4B9C3"/>
-                </a:solidFill>
-                <a:latin typeface="Arial"/>
+                <a:spcPts val="600"/>
+              </a:spcAft>
+              <a:defRPr sz="1600">
+                <a:solidFill>
+                  <a:srgbClr val="C9D1D9"/>
+                </a:solidFill>
+                <a:latin typeface="Calibri"/>
               </a:defRPr>
             </a:pPr>
             <a:r>
@@ -4422,26 +5466,26 @@
           <a:p>
             <a:pPr>
               <a:spcAft>
-                <a:spcPts val="700"/>
-              </a:spcAft>
-              <a:defRPr sz="1700">
-                <a:solidFill>
-                  <a:srgbClr val="B4B9C3"/>
-                </a:solidFill>
-                <a:latin typeface="Arial"/>
-              </a:defRPr>
-            </a:pPr>
-          </a:p>
-          <a:p>
-            <a:pPr>
-              <a:spcAft>
-                <a:spcPts val="700"/>
-              </a:spcAft>
-              <a:defRPr sz="2300" b="1">
+                <a:spcPts val="600"/>
+              </a:spcAft>
+              <a:defRPr sz="1600">
+                <a:solidFill>
+                  <a:srgbClr val="C9D1D9"/>
+                </a:solidFill>
+                <a:latin typeface="Calibri"/>
+              </a:defRPr>
+            </a:pPr>
+          </a:p>
+          <a:p>
+            <a:pPr>
+              <a:spcAft>
+                <a:spcPts val="600"/>
+              </a:spcAft>
+              <a:defRPr sz="2200" b="1">
                 <a:solidFill>
                   <a:srgbClr val="00E676"/>
                 </a:solidFill>
-                <a:latin typeface="Arial"/>
+                <a:latin typeface="Calibri"/>
               </a:defRPr>
             </a:pPr>
             <a:r>
@@ -4451,13 +5495,13 @@
           <a:p>
             <a:pPr>
               <a:spcAft>
-                <a:spcPts val="700"/>
-              </a:spcAft>
-              <a:defRPr sz="1700">
-                <a:solidFill>
-                  <a:srgbClr val="B4B9C3"/>
-                </a:solidFill>
-                <a:latin typeface="Arial"/>
+                <a:spcPts val="600"/>
+              </a:spcAft>
+              <a:defRPr sz="1600">
+                <a:solidFill>
+                  <a:srgbClr val="C9D1D9"/>
+                </a:solidFill>
+                <a:latin typeface="Calibri"/>
               </a:defRPr>
             </a:pPr>
             <a:r>
@@ -4467,13 +5511,13 @@
           <a:p>
             <a:pPr>
               <a:spcAft>
-                <a:spcPts val="700"/>
-              </a:spcAft>
-              <a:defRPr sz="1700">
-                <a:solidFill>
-                  <a:srgbClr val="B4B9C3"/>
-                </a:solidFill>
-                <a:latin typeface="Arial"/>
+                <a:spcPts val="600"/>
+              </a:spcAft>
+              <a:defRPr sz="1600">
+                <a:solidFill>
+                  <a:srgbClr val="C9D1D9"/>
+                </a:solidFill>
+                <a:latin typeface="Calibri"/>
               </a:defRPr>
             </a:pPr>
             <a:r>
@@ -4483,13 +5527,13 @@
           <a:p>
             <a:pPr>
               <a:spcAft>
-                <a:spcPts val="700"/>
-              </a:spcAft>
-              <a:defRPr sz="1700">
-                <a:solidFill>
-                  <a:srgbClr val="B4B9C3"/>
-                </a:solidFill>
-                <a:latin typeface="Arial"/>
+                <a:spcPts val="600"/>
+              </a:spcAft>
+              <a:defRPr sz="1600">
+                <a:solidFill>
+                  <a:srgbClr val="C9D1D9"/>
+                </a:solidFill>
+                <a:latin typeface="Calibri"/>
               </a:defRPr>
             </a:pPr>
             <a:r>
@@ -4526,14 +5570,188 @@
       <p:grpSpPr/>
       <p:sp>
         <p:nvSpPr>
-          <p:cNvPr id="2" name="TextBox 1"/>
+          <p:cNvPr id="2" name="Rectangle 1"/>
+          <p:cNvSpPr/>
+          <p:nvPr/>
+        </p:nvSpPr>
+        <p:spPr>
+          <a:xfrm>
+            <a:off x="0" y="0"/>
+            <a:ext cx="12191695" cy="1051560"/>
+          </a:xfrm>
+          <a:prstGeom prst="rect">
+            <a:avLst/>
+          </a:prstGeom>
+          <a:solidFill>
+            <a:srgbClr val="121821"/>
+          </a:solidFill>
+          <a:ln>
+            <a:noFill/>
+          </a:ln>
+        </p:spPr>
+        <p:style>
+          <a:lnRef idx="1">
+            <a:schemeClr val="accent1"/>
+          </a:lnRef>
+          <a:fillRef idx="3">
+            <a:schemeClr val="accent1"/>
+          </a:fillRef>
+          <a:effectRef idx="2">
+            <a:schemeClr val="accent1"/>
+          </a:effectRef>
+          <a:fontRef idx="minor">
+            <a:schemeClr val="lt1"/>
+          </a:fontRef>
+        </p:style>
+        <p:txBody>
+          <a:bodyPr rtlCol="0" anchor="ctr"/>
+          <a:lstStyle/>
+          <a:p>
+            <a:pPr algn="ctr"/>
+          </a:p>
+        </p:txBody>
+      </p:sp>
+      <p:sp>
+        <p:nvSpPr>
+          <p:cNvPr id="3" name="Rectangle 2"/>
+          <p:cNvSpPr/>
+          <p:nvPr/>
+        </p:nvSpPr>
+        <p:spPr>
+          <a:xfrm>
+            <a:off x="0" y="0"/>
+            <a:ext cx="12191695" cy="73152"/>
+          </a:xfrm>
+          <a:prstGeom prst="rect">
+            <a:avLst/>
+          </a:prstGeom>
+          <a:solidFill>
+            <a:srgbClr val="00E676"/>
+          </a:solidFill>
+          <a:ln>
+            <a:noFill/>
+          </a:ln>
+        </p:spPr>
+        <p:style>
+          <a:lnRef idx="1">
+            <a:schemeClr val="accent1"/>
+          </a:lnRef>
+          <a:fillRef idx="3">
+            <a:schemeClr val="accent1"/>
+          </a:fillRef>
+          <a:effectRef idx="2">
+            <a:schemeClr val="accent1"/>
+          </a:effectRef>
+          <a:fontRef idx="minor">
+            <a:schemeClr val="lt1"/>
+          </a:fontRef>
+        </p:style>
+        <p:txBody>
+          <a:bodyPr rtlCol="0" anchor="ctr"/>
+          <a:lstStyle/>
+          <a:p>
+            <a:pPr algn="ctr"/>
+          </a:p>
+        </p:txBody>
+      </p:sp>
+      <p:sp>
+        <p:nvSpPr>
+          <p:cNvPr id="4" name="Rounded Rectangle 3"/>
+          <p:cNvSpPr/>
+          <p:nvPr/>
+        </p:nvSpPr>
+        <p:spPr>
+          <a:xfrm>
+            <a:off x="9784080" y="201168"/>
+            <a:ext cx="1691640" cy="502920"/>
+          </a:xfrm>
+          <a:prstGeom prst="roundRect">
+            <a:avLst/>
+          </a:prstGeom>
+          <a:solidFill>
+            <a:srgbClr val="388BFD"/>
+          </a:solidFill>
+          <a:ln>
+            <a:noFill/>
+          </a:ln>
+        </p:spPr>
+        <p:style>
+          <a:lnRef idx="1">
+            <a:schemeClr val="accent1"/>
+          </a:lnRef>
+          <a:fillRef idx="3">
+            <a:schemeClr val="accent1"/>
+          </a:fillRef>
+          <a:effectRef idx="2">
+            <a:schemeClr val="accent1"/>
+          </a:effectRef>
+          <a:fontRef idx="minor">
+            <a:schemeClr val="lt1"/>
+          </a:fontRef>
+        </p:style>
+        <p:txBody>
+          <a:bodyPr rtlCol="0" anchor="ctr"/>
+          <a:lstStyle/>
+          <a:p>
+            <a:pPr algn="ctr"/>
+          </a:p>
+        </p:txBody>
+      </p:sp>
+      <p:sp>
+        <p:nvSpPr>
+          <p:cNvPr id="5" name="Rounded Rectangle 4"/>
+          <p:cNvSpPr/>
+          <p:nvPr/>
+        </p:nvSpPr>
+        <p:spPr>
+          <a:xfrm>
+            <a:off x="502920" y="1325880"/>
+            <a:ext cx="11155680" cy="5257800"/>
+          </a:xfrm>
+          <a:prstGeom prst="roundRect">
+            <a:avLst/>
+          </a:prstGeom>
+          <a:solidFill>
+            <a:srgbClr val="161B22"/>
+          </a:solidFill>
+          <a:ln w="12700">
+            <a:solidFill>
+              <a:srgbClr val="308C64"/>
+            </a:solidFill>
+          </a:ln>
+        </p:spPr>
+        <p:style>
+          <a:lnRef idx="1">
+            <a:schemeClr val="accent1"/>
+          </a:lnRef>
+          <a:fillRef idx="3">
+            <a:schemeClr val="accent1"/>
+          </a:fillRef>
+          <a:effectRef idx="2">
+            <a:schemeClr val="accent1"/>
+          </a:effectRef>
+          <a:fontRef idx="minor">
+            <a:schemeClr val="lt1"/>
+          </a:fontRef>
+        </p:style>
+        <p:txBody>
+          <a:bodyPr rtlCol="0" anchor="ctr"/>
+          <a:lstStyle/>
+          <a:p>
+            <a:pPr algn="ctr"/>
+          </a:p>
+        </p:txBody>
+      </p:sp>
+      <p:sp>
+        <p:nvSpPr>
+          <p:cNvPr id="6" name="TextBox 5"/>
           <p:cNvSpPr txBox="1"/>
           <p:nvPr/>
         </p:nvSpPr>
         <p:spPr>
           <a:xfrm>
-            <a:off x="685800" y="502920"/>
-            <a:ext cx="10789920" cy="1005840"/>
+            <a:off x="713232" y="246888"/>
+            <a:ext cx="9692640" cy="777240"/>
           </a:xfrm>
           <a:prstGeom prst="rect">
             <a:avLst/>
@@ -4547,11 +5765,11 @@
           <a:lstStyle/>
           <a:p>
             <a:pPr>
-              <a:defRPr sz="3400" b="1">
+              <a:defRPr sz="3000" b="1">
                 <a:solidFill>
                   <a:srgbClr val="FFFFFF"/>
                 </a:solidFill>
-                <a:latin typeface="Arial"/>
+                <a:latin typeface="Calibri"/>
               </a:defRPr>
             </a:pPr>
             <a:r>
@@ -4562,14 +5780,14 @@
       </p:sp>
       <p:sp>
         <p:nvSpPr>
-          <p:cNvPr id="3" name="TextBox 2"/>
+          <p:cNvPr id="7" name="TextBox 6"/>
           <p:cNvSpPr txBox="1"/>
           <p:nvPr/>
         </p:nvSpPr>
         <p:spPr>
           <a:xfrm>
-            <a:off x="685800" y="1645920"/>
-            <a:ext cx="10789920" cy="4892040"/>
+            <a:off x="804672" y="1627632"/>
+            <a:ext cx="10561320" cy="4681728"/>
           </a:xfrm>
           <a:prstGeom prst="rect">
             <a:avLst/>
@@ -4584,13 +5802,13 @@
           <a:p>
             <a:pPr>
               <a:spcAft>
-                <a:spcPts val="700"/>
-              </a:spcAft>
-              <a:defRPr sz="1700">
-                <a:solidFill>
-                  <a:srgbClr val="B4B9C3"/>
-                </a:solidFill>
-                <a:latin typeface="Arial"/>
+                <a:spcPts val="600"/>
+              </a:spcAft>
+              <a:defRPr sz="1600">
+                <a:solidFill>
+                  <a:srgbClr val="C9D1D9"/>
+                </a:solidFill>
+                <a:latin typeface="Calibri"/>
               </a:defRPr>
             </a:pPr>
             <a:r>
@@ -4600,26 +5818,26 @@
           <a:p>
             <a:pPr>
               <a:spcAft>
-                <a:spcPts val="700"/>
-              </a:spcAft>
-              <a:defRPr sz="1700">
-                <a:solidFill>
-                  <a:srgbClr val="B4B9C3"/>
-                </a:solidFill>
-                <a:latin typeface="Arial"/>
-              </a:defRPr>
-            </a:pPr>
-          </a:p>
-          <a:p>
-            <a:pPr>
-              <a:spcAft>
-                <a:spcPts val="700"/>
-              </a:spcAft>
-              <a:defRPr sz="1700">
-                <a:solidFill>
-                  <a:srgbClr val="B4B9C3"/>
-                </a:solidFill>
-                <a:latin typeface="Arial"/>
+                <a:spcPts val="600"/>
+              </a:spcAft>
+              <a:defRPr sz="1600">
+                <a:solidFill>
+                  <a:srgbClr val="C9D1D9"/>
+                </a:solidFill>
+                <a:latin typeface="Calibri"/>
+              </a:defRPr>
+            </a:pPr>
+          </a:p>
+          <a:p>
+            <a:pPr>
+              <a:spcAft>
+                <a:spcPts val="600"/>
+              </a:spcAft>
+              <a:defRPr sz="1600">
+                <a:solidFill>
+                  <a:srgbClr val="C9D1D9"/>
+                </a:solidFill>
+                <a:latin typeface="Calibri"/>
               </a:defRPr>
             </a:pPr>
             <a:r>
@@ -4629,13 +5847,13 @@
           <a:p>
             <a:pPr>
               <a:spcAft>
-                <a:spcPts val="700"/>
-              </a:spcAft>
-              <a:defRPr sz="1700">
-                <a:solidFill>
-                  <a:srgbClr val="B4B9C3"/>
-                </a:solidFill>
-                <a:latin typeface="Arial"/>
+                <a:spcPts val="600"/>
+              </a:spcAft>
+              <a:defRPr sz="1600">
+                <a:solidFill>
+                  <a:srgbClr val="C9D1D9"/>
+                </a:solidFill>
+                <a:latin typeface="Calibri"/>
               </a:defRPr>
             </a:pPr>
             <a:r>
@@ -4645,26 +5863,26 @@
           <a:p>
             <a:pPr>
               <a:spcAft>
-                <a:spcPts val="700"/>
-              </a:spcAft>
-              <a:defRPr sz="1700">
-                <a:solidFill>
-                  <a:srgbClr val="B4B9C3"/>
-                </a:solidFill>
-                <a:latin typeface="Arial"/>
-              </a:defRPr>
-            </a:pPr>
-          </a:p>
-          <a:p>
-            <a:pPr>
-              <a:spcAft>
-                <a:spcPts val="700"/>
-              </a:spcAft>
-              <a:defRPr sz="1700">
-                <a:solidFill>
-                  <a:srgbClr val="B4B9C3"/>
-                </a:solidFill>
-                <a:latin typeface="Arial"/>
+                <a:spcPts val="600"/>
+              </a:spcAft>
+              <a:defRPr sz="1600">
+                <a:solidFill>
+                  <a:srgbClr val="C9D1D9"/>
+                </a:solidFill>
+                <a:latin typeface="Calibri"/>
+              </a:defRPr>
+            </a:pPr>
+          </a:p>
+          <a:p>
+            <a:pPr>
+              <a:spcAft>
+                <a:spcPts val="600"/>
+              </a:spcAft>
+              <a:defRPr sz="1600">
+                <a:solidFill>
+                  <a:srgbClr val="C9D1D9"/>
+                </a:solidFill>
+                <a:latin typeface="Calibri"/>
               </a:defRPr>
             </a:pPr>
             <a:r>
@@ -4674,13 +5892,13 @@
           <a:p>
             <a:pPr>
               <a:spcAft>
-                <a:spcPts val="700"/>
-              </a:spcAft>
-              <a:defRPr sz="1700">
-                <a:solidFill>
-                  <a:srgbClr val="B4B9C3"/>
-                </a:solidFill>
-                <a:latin typeface="Arial"/>
+                <a:spcPts val="600"/>
+              </a:spcAft>
+              <a:defRPr sz="1600">
+                <a:solidFill>
+                  <a:srgbClr val="C9D1D9"/>
+                </a:solidFill>
+                <a:latin typeface="Calibri"/>
               </a:defRPr>
             </a:pPr>
             <a:r>
@@ -4690,26 +5908,26 @@
           <a:p>
             <a:pPr>
               <a:spcAft>
-                <a:spcPts val="700"/>
-              </a:spcAft>
-              <a:defRPr sz="1700">
-                <a:solidFill>
-                  <a:srgbClr val="B4B9C3"/>
-                </a:solidFill>
-                <a:latin typeface="Arial"/>
-              </a:defRPr>
-            </a:pPr>
-          </a:p>
-          <a:p>
-            <a:pPr>
-              <a:spcAft>
-                <a:spcPts val="700"/>
-              </a:spcAft>
-              <a:defRPr sz="1700">
-                <a:solidFill>
-                  <a:srgbClr val="B4B9C3"/>
-                </a:solidFill>
-                <a:latin typeface="Arial"/>
+                <a:spcPts val="600"/>
+              </a:spcAft>
+              <a:defRPr sz="1600">
+                <a:solidFill>
+                  <a:srgbClr val="C9D1D9"/>
+                </a:solidFill>
+                <a:latin typeface="Calibri"/>
+              </a:defRPr>
+            </a:pPr>
+          </a:p>
+          <a:p>
+            <a:pPr>
+              <a:spcAft>
+                <a:spcPts val="600"/>
+              </a:spcAft>
+              <a:defRPr sz="1600">
+                <a:solidFill>
+                  <a:srgbClr val="C9D1D9"/>
+                </a:solidFill>
+                <a:latin typeface="Calibri"/>
               </a:defRPr>
             </a:pPr>
             <a:r>
@@ -4719,13 +5937,13 @@
           <a:p>
             <a:pPr>
               <a:spcAft>
-                <a:spcPts val="700"/>
-              </a:spcAft>
-              <a:defRPr sz="2300" b="1">
+                <a:spcPts val="600"/>
+              </a:spcAft>
+              <a:defRPr sz="2200" b="1">
                 <a:solidFill>
                   <a:srgbClr val="00E676"/>
                 </a:solidFill>
-                <a:latin typeface="Arial"/>
+                <a:latin typeface="Calibri"/>
               </a:defRPr>
             </a:pPr>
             <a:r>
@@ -4735,13 +5953,13 @@
           <a:p>
             <a:pPr>
               <a:spcAft>
-                <a:spcPts val="700"/>
-              </a:spcAft>
-              <a:defRPr sz="2300" b="1">
+                <a:spcPts val="600"/>
+              </a:spcAft>
+              <a:defRPr sz="2200" b="1">
                 <a:solidFill>
                   <a:srgbClr val="00E676"/>
                 </a:solidFill>
-                <a:latin typeface="Arial"/>
+                <a:latin typeface="Calibri"/>
               </a:defRPr>
             </a:pPr>
             <a:r>
@@ -4778,14 +5996,188 @@
       <p:grpSpPr/>
       <p:sp>
         <p:nvSpPr>
-          <p:cNvPr id="2" name="TextBox 1"/>
+          <p:cNvPr id="2" name="Rectangle 1"/>
+          <p:cNvSpPr/>
+          <p:nvPr/>
+        </p:nvSpPr>
+        <p:spPr>
+          <a:xfrm>
+            <a:off x="0" y="0"/>
+            <a:ext cx="12191695" cy="1051560"/>
+          </a:xfrm>
+          <a:prstGeom prst="rect">
+            <a:avLst/>
+          </a:prstGeom>
+          <a:solidFill>
+            <a:srgbClr val="121821"/>
+          </a:solidFill>
+          <a:ln>
+            <a:noFill/>
+          </a:ln>
+        </p:spPr>
+        <p:style>
+          <a:lnRef idx="1">
+            <a:schemeClr val="accent1"/>
+          </a:lnRef>
+          <a:fillRef idx="3">
+            <a:schemeClr val="accent1"/>
+          </a:fillRef>
+          <a:effectRef idx="2">
+            <a:schemeClr val="accent1"/>
+          </a:effectRef>
+          <a:fontRef idx="minor">
+            <a:schemeClr val="lt1"/>
+          </a:fontRef>
+        </p:style>
+        <p:txBody>
+          <a:bodyPr rtlCol="0" anchor="ctr"/>
+          <a:lstStyle/>
+          <a:p>
+            <a:pPr algn="ctr"/>
+          </a:p>
+        </p:txBody>
+      </p:sp>
+      <p:sp>
+        <p:nvSpPr>
+          <p:cNvPr id="3" name="Rectangle 2"/>
+          <p:cNvSpPr/>
+          <p:nvPr/>
+        </p:nvSpPr>
+        <p:spPr>
+          <a:xfrm>
+            <a:off x="0" y="0"/>
+            <a:ext cx="12191695" cy="73152"/>
+          </a:xfrm>
+          <a:prstGeom prst="rect">
+            <a:avLst/>
+          </a:prstGeom>
+          <a:solidFill>
+            <a:srgbClr val="00E676"/>
+          </a:solidFill>
+          <a:ln>
+            <a:noFill/>
+          </a:ln>
+        </p:spPr>
+        <p:style>
+          <a:lnRef idx="1">
+            <a:schemeClr val="accent1"/>
+          </a:lnRef>
+          <a:fillRef idx="3">
+            <a:schemeClr val="accent1"/>
+          </a:fillRef>
+          <a:effectRef idx="2">
+            <a:schemeClr val="accent1"/>
+          </a:effectRef>
+          <a:fontRef idx="minor">
+            <a:schemeClr val="lt1"/>
+          </a:fontRef>
+        </p:style>
+        <p:txBody>
+          <a:bodyPr rtlCol="0" anchor="ctr"/>
+          <a:lstStyle/>
+          <a:p>
+            <a:pPr algn="ctr"/>
+          </a:p>
+        </p:txBody>
+      </p:sp>
+      <p:sp>
+        <p:nvSpPr>
+          <p:cNvPr id="4" name="Rounded Rectangle 3"/>
+          <p:cNvSpPr/>
+          <p:nvPr/>
+        </p:nvSpPr>
+        <p:spPr>
+          <a:xfrm>
+            <a:off x="9784080" y="201168"/>
+            <a:ext cx="1691640" cy="502920"/>
+          </a:xfrm>
+          <a:prstGeom prst="roundRect">
+            <a:avLst/>
+          </a:prstGeom>
+          <a:solidFill>
+            <a:srgbClr val="388BFD"/>
+          </a:solidFill>
+          <a:ln>
+            <a:noFill/>
+          </a:ln>
+        </p:spPr>
+        <p:style>
+          <a:lnRef idx="1">
+            <a:schemeClr val="accent1"/>
+          </a:lnRef>
+          <a:fillRef idx="3">
+            <a:schemeClr val="accent1"/>
+          </a:fillRef>
+          <a:effectRef idx="2">
+            <a:schemeClr val="accent1"/>
+          </a:effectRef>
+          <a:fontRef idx="minor">
+            <a:schemeClr val="lt1"/>
+          </a:fontRef>
+        </p:style>
+        <p:txBody>
+          <a:bodyPr rtlCol="0" anchor="ctr"/>
+          <a:lstStyle/>
+          <a:p>
+            <a:pPr algn="ctr"/>
+          </a:p>
+        </p:txBody>
+      </p:sp>
+      <p:sp>
+        <p:nvSpPr>
+          <p:cNvPr id="5" name="Rounded Rectangle 4"/>
+          <p:cNvSpPr/>
+          <p:nvPr/>
+        </p:nvSpPr>
+        <p:spPr>
+          <a:xfrm>
+            <a:off x="502920" y="1325880"/>
+            <a:ext cx="11155680" cy="5257800"/>
+          </a:xfrm>
+          <a:prstGeom prst="roundRect">
+            <a:avLst/>
+          </a:prstGeom>
+          <a:solidFill>
+            <a:srgbClr val="161B22"/>
+          </a:solidFill>
+          <a:ln w="12700">
+            <a:solidFill>
+              <a:srgbClr val="308C64"/>
+            </a:solidFill>
+          </a:ln>
+        </p:spPr>
+        <p:style>
+          <a:lnRef idx="1">
+            <a:schemeClr val="accent1"/>
+          </a:lnRef>
+          <a:fillRef idx="3">
+            <a:schemeClr val="accent1"/>
+          </a:fillRef>
+          <a:effectRef idx="2">
+            <a:schemeClr val="accent1"/>
+          </a:effectRef>
+          <a:fontRef idx="minor">
+            <a:schemeClr val="lt1"/>
+          </a:fontRef>
+        </p:style>
+        <p:txBody>
+          <a:bodyPr rtlCol="0" anchor="ctr"/>
+          <a:lstStyle/>
+          <a:p>
+            <a:pPr algn="ctr"/>
+          </a:p>
+        </p:txBody>
+      </p:sp>
+      <p:sp>
+        <p:nvSpPr>
+          <p:cNvPr id="6" name="TextBox 5"/>
           <p:cNvSpPr txBox="1"/>
           <p:nvPr/>
         </p:nvSpPr>
         <p:spPr>
           <a:xfrm>
-            <a:off x="685800" y="502920"/>
-            <a:ext cx="10789920" cy="1005840"/>
+            <a:off x="713232" y="246888"/>
+            <a:ext cx="9692640" cy="777240"/>
           </a:xfrm>
           <a:prstGeom prst="rect">
             <a:avLst/>
@@ -4799,11 +6191,11 @@
           <a:lstStyle/>
           <a:p>
             <a:pPr>
-              <a:defRPr sz="3400" b="1">
+              <a:defRPr sz="3000" b="1">
                 <a:solidFill>
                   <a:srgbClr val="FFFFFF"/>
                 </a:solidFill>
-                <a:latin typeface="Arial"/>
+                <a:latin typeface="Calibri"/>
               </a:defRPr>
             </a:pPr>
             <a:r>
@@ -4814,14 +6206,14 @@
       </p:sp>
       <p:sp>
         <p:nvSpPr>
-          <p:cNvPr id="3" name="TextBox 2"/>
+          <p:cNvPr id="7" name="TextBox 6"/>
           <p:cNvSpPr txBox="1"/>
           <p:nvPr/>
         </p:nvSpPr>
         <p:spPr>
           <a:xfrm>
-            <a:off x="685800" y="1645920"/>
-            <a:ext cx="10789920" cy="4892040"/>
+            <a:off x="804672" y="1627632"/>
+            <a:ext cx="10561320" cy="4681728"/>
           </a:xfrm>
           <a:prstGeom prst="rect">
             <a:avLst/>
@@ -4836,13 +6228,13 @@
           <a:p>
             <a:pPr>
               <a:spcAft>
-                <a:spcPts val="700"/>
-              </a:spcAft>
-              <a:defRPr sz="2300" b="1">
+                <a:spcPts val="600"/>
+              </a:spcAft>
+              <a:defRPr sz="2200" b="1">
                 <a:solidFill>
                   <a:srgbClr val="00E676"/>
                 </a:solidFill>
-                <a:latin typeface="Arial"/>
+                <a:latin typeface="Calibri"/>
               </a:defRPr>
             </a:pPr>
             <a:r>
@@ -4852,26 +6244,26 @@
           <a:p>
             <a:pPr>
               <a:spcAft>
-                <a:spcPts val="700"/>
-              </a:spcAft>
-              <a:defRPr sz="1700">
-                <a:solidFill>
-                  <a:srgbClr val="B4B9C3"/>
-                </a:solidFill>
-                <a:latin typeface="Arial"/>
-              </a:defRPr>
-            </a:pPr>
-          </a:p>
-          <a:p>
-            <a:pPr>
-              <a:spcAft>
-                <a:spcPts val="700"/>
-              </a:spcAft>
-              <a:defRPr sz="1700">
-                <a:solidFill>
-                  <a:srgbClr val="B4B9C3"/>
-                </a:solidFill>
-                <a:latin typeface="Arial"/>
+                <a:spcPts val="600"/>
+              </a:spcAft>
+              <a:defRPr sz="1600">
+                <a:solidFill>
+                  <a:srgbClr val="C9D1D9"/>
+                </a:solidFill>
+                <a:latin typeface="Calibri"/>
+              </a:defRPr>
+            </a:pPr>
+          </a:p>
+          <a:p>
+            <a:pPr>
+              <a:spcAft>
+                <a:spcPts val="600"/>
+              </a:spcAft>
+              <a:defRPr sz="1600">
+                <a:solidFill>
+                  <a:srgbClr val="C9D1D9"/>
+                </a:solidFill>
+                <a:latin typeface="Calibri"/>
               </a:defRPr>
             </a:pPr>
             <a:r>
@@ -4881,13 +6273,13 @@
           <a:p>
             <a:pPr>
               <a:spcAft>
-                <a:spcPts val="700"/>
-              </a:spcAft>
-              <a:defRPr sz="1700">
-                <a:solidFill>
-                  <a:srgbClr val="B4B9C3"/>
-                </a:solidFill>
-                <a:latin typeface="Arial"/>
+                <a:spcPts val="600"/>
+              </a:spcAft>
+              <a:defRPr sz="1600">
+                <a:solidFill>
+                  <a:srgbClr val="C9D1D9"/>
+                </a:solidFill>
+                <a:latin typeface="Calibri"/>
               </a:defRPr>
             </a:pPr>
             <a:r>
@@ -4897,26 +6289,26 @@
           <a:p>
             <a:pPr>
               <a:spcAft>
-                <a:spcPts val="700"/>
-              </a:spcAft>
-              <a:defRPr sz="1700">
-                <a:solidFill>
-                  <a:srgbClr val="B4B9C3"/>
-                </a:solidFill>
-                <a:latin typeface="Arial"/>
-              </a:defRPr>
-            </a:pPr>
-          </a:p>
-          <a:p>
-            <a:pPr>
-              <a:spcAft>
-                <a:spcPts val="700"/>
-              </a:spcAft>
-              <a:defRPr sz="1700">
-                <a:solidFill>
-                  <a:srgbClr val="B4B9C3"/>
-                </a:solidFill>
-                <a:latin typeface="Arial"/>
+                <a:spcPts val="600"/>
+              </a:spcAft>
+              <a:defRPr sz="1600">
+                <a:solidFill>
+                  <a:srgbClr val="C9D1D9"/>
+                </a:solidFill>
+                <a:latin typeface="Calibri"/>
+              </a:defRPr>
+            </a:pPr>
+          </a:p>
+          <a:p>
+            <a:pPr>
+              <a:spcAft>
+                <a:spcPts val="600"/>
+              </a:spcAft>
+              <a:defRPr sz="1600">
+                <a:solidFill>
+                  <a:srgbClr val="C9D1D9"/>
+                </a:solidFill>
+                <a:latin typeface="Calibri"/>
               </a:defRPr>
             </a:pPr>
             <a:r>
@@ -4926,13 +6318,13 @@
           <a:p>
             <a:pPr>
               <a:spcAft>
-                <a:spcPts val="700"/>
-              </a:spcAft>
-              <a:defRPr sz="1700">
-                <a:solidFill>
-                  <a:srgbClr val="B4B9C3"/>
-                </a:solidFill>
-                <a:latin typeface="Arial"/>
+                <a:spcPts val="600"/>
+              </a:spcAft>
+              <a:defRPr sz="1600">
+                <a:solidFill>
+                  <a:srgbClr val="C9D1D9"/>
+                </a:solidFill>
+                <a:latin typeface="Calibri"/>
               </a:defRPr>
             </a:pPr>
             <a:r>
@@ -4942,13 +6334,13 @@
           <a:p>
             <a:pPr>
               <a:spcAft>
-                <a:spcPts val="700"/>
-              </a:spcAft>
-              <a:defRPr sz="1700">
-                <a:solidFill>
-                  <a:srgbClr val="B4B9C3"/>
-                </a:solidFill>
-                <a:latin typeface="Arial"/>
+                <a:spcPts val="600"/>
+              </a:spcAft>
+              <a:defRPr sz="1600">
+                <a:solidFill>
+                  <a:srgbClr val="C9D1D9"/>
+                </a:solidFill>
+                <a:latin typeface="Calibri"/>
               </a:defRPr>
             </a:pPr>
             <a:r>
@@ -4958,13 +6350,13 @@
           <a:p>
             <a:pPr>
               <a:spcAft>
-                <a:spcPts val="700"/>
-              </a:spcAft>
-              <a:defRPr sz="1700">
-                <a:solidFill>
-                  <a:srgbClr val="B4B9C3"/>
-                </a:solidFill>
-                <a:latin typeface="Arial"/>
+                <a:spcPts val="600"/>
+              </a:spcAft>
+              <a:defRPr sz="1600">
+                <a:solidFill>
+                  <a:srgbClr val="C9D1D9"/>
+                </a:solidFill>
+                <a:latin typeface="Calibri"/>
               </a:defRPr>
             </a:pPr>
             <a:r>
@@ -5001,14 +6393,188 @@
       <p:grpSpPr/>
       <p:sp>
         <p:nvSpPr>
-          <p:cNvPr id="2" name="TextBox 1"/>
+          <p:cNvPr id="2" name="Rectangle 1"/>
+          <p:cNvSpPr/>
+          <p:nvPr/>
+        </p:nvSpPr>
+        <p:spPr>
+          <a:xfrm>
+            <a:off x="0" y="0"/>
+            <a:ext cx="12191695" cy="1051560"/>
+          </a:xfrm>
+          <a:prstGeom prst="rect">
+            <a:avLst/>
+          </a:prstGeom>
+          <a:solidFill>
+            <a:srgbClr val="121821"/>
+          </a:solidFill>
+          <a:ln>
+            <a:noFill/>
+          </a:ln>
+        </p:spPr>
+        <p:style>
+          <a:lnRef idx="1">
+            <a:schemeClr val="accent1"/>
+          </a:lnRef>
+          <a:fillRef idx="3">
+            <a:schemeClr val="accent1"/>
+          </a:fillRef>
+          <a:effectRef idx="2">
+            <a:schemeClr val="accent1"/>
+          </a:effectRef>
+          <a:fontRef idx="minor">
+            <a:schemeClr val="lt1"/>
+          </a:fontRef>
+        </p:style>
+        <p:txBody>
+          <a:bodyPr rtlCol="0" anchor="ctr"/>
+          <a:lstStyle/>
+          <a:p>
+            <a:pPr algn="ctr"/>
+          </a:p>
+        </p:txBody>
+      </p:sp>
+      <p:sp>
+        <p:nvSpPr>
+          <p:cNvPr id="3" name="Rectangle 2"/>
+          <p:cNvSpPr/>
+          <p:nvPr/>
+        </p:nvSpPr>
+        <p:spPr>
+          <a:xfrm>
+            <a:off x="0" y="0"/>
+            <a:ext cx="12191695" cy="73152"/>
+          </a:xfrm>
+          <a:prstGeom prst="rect">
+            <a:avLst/>
+          </a:prstGeom>
+          <a:solidFill>
+            <a:srgbClr val="00E676"/>
+          </a:solidFill>
+          <a:ln>
+            <a:noFill/>
+          </a:ln>
+        </p:spPr>
+        <p:style>
+          <a:lnRef idx="1">
+            <a:schemeClr val="accent1"/>
+          </a:lnRef>
+          <a:fillRef idx="3">
+            <a:schemeClr val="accent1"/>
+          </a:fillRef>
+          <a:effectRef idx="2">
+            <a:schemeClr val="accent1"/>
+          </a:effectRef>
+          <a:fontRef idx="minor">
+            <a:schemeClr val="lt1"/>
+          </a:fontRef>
+        </p:style>
+        <p:txBody>
+          <a:bodyPr rtlCol="0" anchor="ctr"/>
+          <a:lstStyle/>
+          <a:p>
+            <a:pPr algn="ctr"/>
+          </a:p>
+        </p:txBody>
+      </p:sp>
+      <p:sp>
+        <p:nvSpPr>
+          <p:cNvPr id="4" name="Rounded Rectangle 3"/>
+          <p:cNvSpPr/>
+          <p:nvPr/>
+        </p:nvSpPr>
+        <p:spPr>
+          <a:xfrm>
+            <a:off x="9784080" y="201168"/>
+            <a:ext cx="1691640" cy="502920"/>
+          </a:xfrm>
+          <a:prstGeom prst="roundRect">
+            <a:avLst/>
+          </a:prstGeom>
+          <a:solidFill>
+            <a:srgbClr val="388BFD"/>
+          </a:solidFill>
+          <a:ln>
+            <a:noFill/>
+          </a:ln>
+        </p:spPr>
+        <p:style>
+          <a:lnRef idx="1">
+            <a:schemeClr val="accent1"/>
+          </a:lnRef>
+          <a:fillRef idx="3">
+            <a:schemeClr val="accent1"/>
+          </a:fillRef>
+          <a:effectRef idx="2">
+            <a:schemeClr val="accent1"/>
+          </a:effectRef>
+          <a:fontRef idx="minor">
+            <a:schemeClr val="lt1"/>
+          </a:fontRef>
+        </p:style>
+        <p:txBody>
+          <a:bodyPr rtlCol="0" anchor="ctr"/>
+          <a:lstStyle/>
+          <a:p>
+            <a:pPr algn="ctr"/>
+          </a:p>
+        </p:txBody>
+      </p:sp>
+      <p:sp>
+        <p:nvSpPr>
+          <p:cNvPr id="5" name="Rounded Rectangle 4"/>
+          <p:cNvSpPr/>
+          <p:nvPr/>
+        </p:nvSpPr>
+        <p:spPr>
+          <a:xfrm>
+            <a:off x="502920" y="1325880"/>
+            <a:ext cx="11155680" cy="5257800"/>
+          </a:xfrm>
+          <a:prstGeom prst="roundRect">
+            <a:avLst/>
+          </a:prstGeom>
+          <a:solidFill>
+            <a:srgbClr val="161B22"/>
+          </a:solidFill>
+          <a:ln w="12700">
+            <a:solidFill>
+              <a:srgbClr val="308C64"/>
+            </a:solidFill>
+          </a:ln>
+        </p:spPr>
+        <p:style>
+          <a:lnRef idx="1">
+            <a:schemeClr val="accent1"/>
+          </a:lnRef>
+          <a:fillRef idx="3">
+            <a:schemeClr val="accent1"/>
+          </a:fillRef>
+          <a:effectRef idx="2">
+            <a:schemeClr val="accent1"/>
+          </a:effectRef>
+          <a:fontRef idx="minor">
+            <a:schemeClr val="lt1"/>
+          </a:fontRef>
+        </p:style>
+        <p:txBody>
+          <a:bodyPr rtlCol="0" anchor="ctr"/>
+          <a:lstStyle/>
+          <a:p>
+            <a:pPr algn="ctr"/>
+          </a:p>
+        </p:txBody>
+      </p:sp>
+      <p:sp>
+        <p:nvSpPr>
+          <p:cNvPr id="6" name="TextBox 5"/>
           <p:cNvSpPr txBox="1"/>
           <p:nvPr/>
         </p:nvSpPr>
         <p:spPr>
           <a:xfrm>
-            <a:off x="685800" y="502920"/>
-            <a:ext cx="10789920" cy="1005840"/>
+            <a:off x="713232" y="246888"/>
+            <a:ext cx="9692640" cy="777240"/>
           </a:xfrm>
           <a:prstGeom prst="rect">
             <a:avLst/>
@@ -5022,11 +6588,11 @@
           <a:lstStyle/>
           <a:p>
             <a:pPr>
-              <a:defRPr sz="3400" b="1">
+              <a:defRPr sz="3000" b="1">
                 <a:solidFill>
                   <a:srgbClr val="FFFFFF"/>
                 </a:solidFill>
-                <a:latin typeface="Arial"/>
+                <a:latin typeface="Calibri"/>
               </a:defRPr>
             </a:pPr>
             <a:r>
@@ -5037,14 +6603,14 @@
       </p:sp>
       <p:sp>
         <p:nvSpPr>
-          <p:cNvPr id="3" name="TextBox 2"/>
+          <p:cNvPr id="7" name="TextBox 6"/>
           <p:cNvSpPr txBox="1"/>
           <p:nvPr/>
         </p:nvSpPr>
         <p:spPr>
           <a:xfrm>
-            <a:off x="685800" y="1645920"/>
-            <a:ext cx="10789920" cy="4892040"/>
+            <a:off x="804672" y="1627632"/>
+            <a:ext cx="10561320" cy="4681728"/>
           </a:xfrm>
           <a:prstGeom prst="rect">
             <a:avLst/>
@@ -5059,13 +6625,13 @@
           <a:p>
             <a:pPr>
               <a:spcAft>
-                <a:spcPts val="700"/>
-              </a:spcAft>
-              <a:defRPr sz="1700">
-                <a:solidFill>
-                  <a:srgbClr val="B4B9C3"/>
-                </a:solidFill>
-                <a:latin typeface="Arial"/>
+                <a:spcPts val="600"/>
+              </a:spcAft>
+              <a:defRPr sz="1600">
+                <a:solidFill>
+                  <a:srgbClr val="C9D1D9"/>
+                </a:solidFill>
+                <a:latin typeface="Calibri"/>
               </a:defRPr>
             </a:pPr>
             <a:r>
@@ -5075,13 +6641,13 @@
           <a:p>
             <a:pPr>
               <a:spcAft>
-                <a:spcPts val="700"/>
-              </a:spcAft>
-              <a:defRPr sz="2300" b="1">
+                <a:spcPts val="600"/>
+              </a:spcAft>
+              <a:defRPr sz="2200" b="1">
                 <a:solidFill>
                   <a:srgbClr val="00E676"/>
                 </a:solidFill>
-                <a:latin typeface="Arial"/>
+                <a:latin typeface="Calibri"/>
               </a:defRPr>
             </a:pPr>
             <a:r>
@@ -5091,13 +6657,13 @@
           <a:p>
             <a:pPr>
               <a:spcAft>
-                <a:spcPts val="700"/>
-              </a:spcAft>
-              <a:defRPr sz="2300" b="1">
+                <a:spcPts val="600"/>
+              </a:spcAft>
+              <a:defRPr sz="2200" b="1">
                 <a:solidFill>
                   <a:srgbClr val="00E676"/>
                 </a:solidFill>
-                <a:latin typeface="Arial"/>
+                <a:latin typeface="Calibri"/>
               </a:defRPr>
             </a:pPr>
             <a:r>
@@ -5107,13 +6673,13 @@
           <a:p>
             <a:pPr>
               <a:spcAft>
-                <a:spcPts val="700"/>
-              </a:spcAft>
-              <a:defRPr sz="2300" b="1">
+                <a:spcPts val="600"/>
+              </a:spcAft>
+              <a:defRPr sz="2200" b="1">
                 <a:solidFill>
                   <a:srgbClr val="00E676"/>
                 </a:solidFill>
-                <a:latin typeface="Arial"/>
+                <a:latin typeface="Calibri"/>
               </a:defRPr>
             </a:pPr>
             <a:r>
@@ -5123,13 +6689,13 @@
           <a:p>
             <a:pPr>
               <a:spcAft>
-                <a:spcPts val="700"/>
-              </a:spcAft>
-              <a:defRPr sz="2300" b="1">
+                <a:spcPts val="600"/>
+              </a:spcAft>
+              <a:defRPr sz="2200" b="1">
                 <a:solidFill>
                   <a:srgbClr val="00E676"/>
                 </a:solidFill>
-                <a:latin typeface="Arial"/>
+                <a:latin typeface="Calibri"/>
               </a:defRPr>
             </a:pPr>
             <a:r>
@@ -5139,13 +6705,13 @@
           <a:p>
             <a:pPr>
               <a:spcAft>
-                <a:spcPts val="700"/>
-              </a:spcAft>
-              <a:defRPr sz="2300" b="1">
+                <a:spcPts val="600"/>
+              </a:spcAft>
+              <a:defRPr sz="2200" b="1">
                 <a:solidFill>
                   <a:srgbClr val="00E676"/>
                 </a:solidFill>
-                <a:latin typeface="Arial"/>
+                <a:latin typeface="Calibri"/>
               </a:defRPr>
             </a:pPr>
             <a:r>
@@ -5182,14 +6748,188 @@
       <p:grpSpPr/>
       <p:sp>
         <p:nvSpPr>
-          <p:cNvPr id="2" name="TextBox 1"/>
+          <p:cNvPr id="2" name="Rectangle 1"/>
+          <p:cNvSpPr/>
+          <p:nvPr/>
+        </p:nvSpPr>
+        <p:spPr>
+          <a:xfrm>
+            <a:off x="0" y="0"/>
+            <a:ext cx="12191695" cy="1051560"/>
+          </a:xfrm>
+          <a:prstGeom prst="rect">
+            <a:avLst/>
+          </a:prstGeom>
+          <a:solidFill>
+            <a:srgbClr val="121821"/>
+          </a:solidFill>
+          <a:ln>
+            <a:noFill/>
+          </a:ln>
+        </p:spPr>
+        <p:style>
+          <a:lnRef idx="1">
+            <a:schemeClr val="accent1"/>
+          </a:lnRef>
+          <a:fillRef idx="3">
+            <a:schemeClr val="accent1"/>
+          </a:fillRef>
+          <a:effectRef idx="2">
+            <a:schemeClr val="accent1"/>
+          </a:effectRef>
+          <a:fontRef idx="minor">
+            <a:schemeClr val="lt1"/>
+          </a:fontRef>
+        </p:style>
+        <p:txBody>
+          <a:bodyPr rtlCol="0" anchor="ctr"/>
+          <a:lstStyle/>
+          <a:p>
+            <a:pPr algn="ctr"/>
+          </a:p>
+        </p:txBody>
+      </p:sp>
+      <p:sp>
+        <p:nvSpPr>
+          <p:cNvPr id="3" name="Rectangle 2"/>
+          <p:cNvSpPr/>
+          <p:nvPr/>
+        </p:nvSpPr>
+        <p:spPr>
+          <a:xfrm>
+            <a:off x="0" y="0"/>
+            <a:ext cx="12191695" cy="73152"/>
+          </a:xfrm>
+          <a:prstGeom prst="rect">
+            <a:avLst/>
+          </a:prstGeom>
+          <a:solidFill>
+            <a:srgbClr val="00E676"/>
+          </a:solidFill>
+          <a:ln>
+            <a:noFill/>
+          </a:ln>
+        </p:spPr>
+        <p:style>
+          <a:lnRef idx="1">
+            <a:schemeClr val="accent1"/>
+          </a:lnRef>
+          <a:fillRef idx="3">
+            <a:schemeClr val="accent1"/>
+          </a:fillRef>
+          <a:effectRef idx="2">
+            <a:schemeClr val="accent1"/>
+          </a:effectRef>
+          <a:fontRef idx="minor">
+            <a:schemeClr val="lt1"/>
+          </a:fontRef>
+        </p:style>
+        <p:txBody>
+          <a:bodyPr rtlCol="0" anchor="ctr"/>
+          <a:lstStyle/>
+          <a:p>
+            <a:pPr algn="ctr"/>
+          </a:p>
+        </p:txBody>
+      </p:sp>
+      <p:sp>
+        <p:nvSpPr>
+          <p:cNvPr id="4" name="Rounded Rectangle 3"/>
+          <p:cNvSpPr/>
+          <p:nvPr/>
+        </p:nvSpPr>
+        <p:spPr>
+          <a:xfrm>
+            <a:off x="9784080" y="201168"/>
+            <a:ext cx="1691640" cy="502920"/>
+          </a:xfrm>
+          <a:prstGeom prst="roundRect">
+            <a:avLst/>
+          </a:prstGeom>
+          <a:solidFill>
+            <a:srgbClr val="388BFD"/>
+          </a:solidFill>
+          <a:ln>
+            <a:noFill/>
+          </a:ln>
+        </p:spPr>
+        <p:style>
+          <a:lnRef idx="1">
+            <a:schemeClr val="accent1"/>
+          </a:lnRef>
+          <a:fillRef idx="3">
+            <a:schemeClr val="accent1"/>
+          </a:fillRef>
+          <a:effectRef idx="2">
+            <a:schemeClr val="accent1"/>
+          </a:effectRef>
+          <a:fontRef idx="minor">
+            <a:schemeClr val="lt1"/>
+          </a:fontRef>
+        </p:style>
+        <p:txBody>
+          <a:bodyPr rtlCol="0" anchor="ctr"/>
+          <a:lstStyle/>
+          <a:p>
+            <a:pPr algn="ctr"/>
+          </a:p>
+        </p:txBody>
+      </p:sp>
+      <p:sp>
+        <p:nvSpPr>
+          <p:cNvPr id="5" name="Rounded Rectangle 4"/>
+          <p:cNvSpPr/>
+          <p:nvPr/>
+        </p:nvSpPr>
+        <p:spPr>
+          <a:xfrm>
+            <a:off x="502920" y="1325880"/>
+            <a:ext cx="11155680" cy="5257800"/>
+          </a:xfrm>
+          <a:prstGeom prst="roundRect">
+            <a:avLst/>
+          </a:prstGeom>
+          <a:solidFill>
+            <a:srgbClr val="161B22"/>
+          </a:solidFill>
+          <a:ln w="12700">
+            <a:solidFill>
+              <a:srgbClr val="308C64"/>
+            </a:solidFill>
+          </a:ln>
+        </p:spPr>
+        <p:style>
+          <a:lnRef idx="1">
+            <a:schemeClr val="accent1"/>
+          </a:lnRef>
+          <a:fillRef idx="3">
+            <a:schemeClr val="accent1"/>
+          </a:fillRef>
+          <a:effectRef idx="2">
+            <a:schemeClr val="accent1"/>
+          </a:effectRef>
+          <a:fontRef idx="minor">
+            <a:schemeClr val="lt1"/>
+          </a:fontRef>
+        </p:style>
+        <p:txBody>
+          <a:bodyPr rtlCol="0" anchor="ctr"/>
+          <a:lstStyle/>
+          <a:p>
+            <a:pPr algn="ctr"/>
+          </a:p>
+        </p:txBody>
+      </p:sp>
+      <p:sp>
+        <p:nvSpPr>
+          <p:cNvPr id="6" name="TextBox 5"/>
           <p:cNvSpPr txBox="1"/>
           <p:nvPr/>
         </p:nvSpPr>
         <p:spPr>
           <a:xfrm>
-            <a:off x="685800" y="502920"/>
-            <a:ext cx="10789920" cy="1005840"/>
+            <a:off x="713232" y="246888"/>
+            <a:ext cx="9692640" cy="777240"/>
           </a:xfrm>
           <a:prstGeom prst="rect">
             <a:avLst/>
@@ -5203,11 +6943,11 @@
           <a:lstStyle/>
           <a:p>
             <a:pPr>
-              <a:defRPr sz="3400" b="1">
+              <a:defRPr sz="3000" b="1">
                 <a:solidFill>
                   <a:srgbClr val="FFFFFF"/>
                 </a:solidFill>
-                <a:latin typeface="Arial"/>
+                <a:latin typeface="Calibri"/>
               </a:defRPr>
             </a:pPr>
             <a:r>
@@ -5218,14 +6958,14 @@
       </p:sp>
       <p:sp>
         <p:nvSpPr>
-          <p:cNvPr id="3" name="TextBox 2"/>
+          <p:cNvPr id="7" name="TextBox 6"/>
           <p:cNvSpPr txBox="1"/>
           <p:nvPr/>
         </p:nvSpPr>
         <p:spPr>
           <a:xfrm>
-            <a:off x="685800" y="1645920"/>
-            <a:ext cx="10789920" cy="4892040"/>
+            <a:off x="804672" y="1627632"/>
+            <a:ext cx="10561320" cy="4681728"/>
           </a:xfrm>
           <a:prstGeom prst="rect">
             <a:avLst/>
@@ -5240,13 +6980,13 @@
           <a:p>
             <a:pPr>
               <a:spcAft>
-                <a:spcPts val="700"/>
-              </a:spcAft>
-              <a:defRPr sz="1700">
-                <a:solidFill>
-                  <a:srgbClr val="B4B9C3"/>
-                </a:solidFill>
-                <a:latin typeface="Arial"/>
+                <a:spcPts val="600"/>
+              </a:spcAft>
+              <a:defRPr sz="1600">
+                <a:solidFill>
+                  <a:srgbClr val="C9D1D9"/>
+                </a:solidFill>
+                <a:latin typeface="Calibri"/>
               </a:defRPr>
             </a:pPr>
             <a:r>
@@ -5256,26 +6996,26 @@
           <a:p>
             <a:pPr>
               <a:spcAft>
-                <a:spcPts val="700"/>
-              </a:spcAft>
-              <a:defRPr sz="1700">
-                <a:solidFill>
-                  <a:srgbClr val="B4B9C3"/>
-                </a:solidFill>
-                <a:latin typeface="Arial"/>
-              </a:defRPr>
-            </a:pPr>
-          </a:p>
-          <a:p>
-            <a:pPr>
-              <a:spcAft>
-                <a:spcPts val="700"/>
-              </a:spcAft>
-              <a:defRPr sz="2300" b="1">
+                <a:spcPts val="600"/>
+              </a:spcAft>
+              <a:defRPr sz="1600">
+                <a:solidFill>
+                  <a:srgbClr val="C9D1D9"/>
+                </a:solidFill>
+                <a:latin typeface="Calibri"/>
+              </a:defRPr>
+            </a:pPr>
+          </a:p>
+          <a:p>
+            <a:pPr>
+              <a:spcAft>
+                <a:spcPts val="600"/>
+              </a:spcAft>
+              <a:defRPr sz="2200" b="1">
                 <a:solidFill>
                   <a:srgbClr val="00E676"/>
                 </a:solidFill>
-                <a:latin typeface="Arial"/>
+                <a:latin typeface="Calibri"/>
               </a:defRPr>
             </a:pPr>
             <a:r>
@@ -5285,13 +7025,13 @@
           <a:p>
             <a:pPr>
               <a:spcAft>
-                <a:spcPts val="700"/>
-              </a:spcAft>
-              <a:defRPr sz="1700">
-                <a:solidFill>
-                  <a:srgbClr val="B4B9C3"/>
-                </a:solidFill>
-                <a:latin typeface="Arial"/>
+                <a:spcPts val="600"/>
+              </a:spcAft>
+              <a:defRPr sz="1600">
+                <a:solidFill>
+                  <a:srgbClr val="C9D1D9"/>
+                </a:solidFill>
+                <a:latin typeface="Calibri"/>
               </a:defRPr>
             </a:pPr>
             <a:r>
@@ -5301,26 +7041,26 @@
           <a:p>
             <a:pPr>
               <a:spcAft>
-                <a:spcPts val="700"/>
-              </a:spcAft>
-              <a:defRPr sz="1700">
-                <a:solidFill>
-                  <a:srgbClr val="B4B9C3"/>
-                </a:solidFill>
-                <a:latin typeface="Arial"/>
-              </a:defRPr>
-            </a:pPr>
-          </a:p>
-          <a:p>
-            <a:pPr>
-              <a:spcAft>
-                <a:spcPts val="700"/>
-              </a:spcAft>
-              <a:defRPr sz="2300" b="1">
+                <a:spcPts val="600"/>
+              </a:spcAft>
+              <a:defRPr sz="1600">
+                <a:solidFill>
+                  <a:srgbClr val="C9D1D9"/>
+                </a:solidFill>
+                <a:latin typeface="Calibri"/>
+              </a:defRPr>
+            </a:pPr>
+          </a:p>
+          <a:p>
+            <a:pPr>
+              <a:spcAft>
+                <a:spcPts val="600"/>
+              </a:spcAft>
+              <a:defRPr sz="2200" b="1">
                 <a:solidFill>
                   <a:srgbClr val="00E676"/>
                 </a:solidFill>
-                <a:latin typeface="Arial"/>
+                <a:latin typeface="Calibri"/>
               </a:defRPr>
             </a:pPr>
             <a:r>
@@ -5330,13 +7070,13 @@
           <a:p>
             <a:pPr>
               <a:spcAft>
-                <a:spcPts val="700"/>
-              </a:spcAft>
-              <a:defRPr sz="1700">
-                <a:solidFill>
-                  <a:srgbClr val="B4B9C3"/>
-                </a:solidFill>
-                <a:latin typeface="Arial"/>
+                <a:spcPts val="600"/>
+              </a:spcAft>
+              <a:defRPr sz="1600">
+                <a:solidFill>
+                  <a:srgbClr val="C9D1D9"/>
+                </a:solidFill>
+                <a:latin typeface="Calibri"/>
               </a:defRPr>
             </a:pPr>
             <a:r>
@@ -5346,26 +7086,26 @@
           <a:p>
             <a:pPr>
               <a:spcAft>
-                <a:spcPts val="700"/>
-              </a:spcAft>
-              <a:defRPr sz="1700">
-                <a:solidFill>
-                  <a:srgbClr val="B4B9C3"/>
-                </a:solidFill>
-                <a:latin typeface="Arial"/>
-              </a:defRPr>
-            </a:pPr>
-          </a:p>
-          <a:p>
-            <a:pPr>
-              <a:spcAft>
-                <a:spcPts val="700"/>
-              </a:spcAft>
-              <a:defRPr sz="2300" b="1">
+                <a:spcPts val="600"/>
+              </a:spcAft>
+              <a:defRPr sz="1600">
+                <a:solidFill>
+                  <a:srgbClr val="C9D1D9"/>
+                </a:solidFill>
+                <a:latin typeface="Calibri"/>
+              </a:defRPr>
+            </a:pPr>
+          </a:p>
+          <a:p>
+            <a:pPr>
+              <a:spcAft>
+                <a:spcPts val="600"/>
+              </a:spcAft>
+              <a:defRPr sz="2200" b="1">
                 <a:solidFill>
                   <a:srgbClr val="00E676"/>
                 </a:solidFill>
-                <a:latin typeface="Arial"/>
+                <a:latin typeface="Calibri"/>
               </a:defRPr>
             </a:pPr>
             <a:r>
@@ -5375,13 +7115,13 @@
           <a:p>
             <a:pPr>
               <a:spcAft>
-                <a:spcPts val="700"/>
-              </a:spcAft>
-              <a:defRPr sz="1700">
-                <a:solidFill>
-                  <a:srgbClr val="B4B9C3"/>
-                </a:solidFill>
-                <a:latin typeface="Arial"/>
+                <a:spcPts val="600"/>
+              </a:spcAft>
+              <a:defRPr sz="1600">
+                <a:solidFill>
+                  <a:srgbClr val="C9D1D9"/>
+                </a:solidFill>
+                <a:latin typeface="Calibri"/>
               </a:defRPr>
             </a:pPr>
             <a:r>
@@ -5418,14 +7158,188 @@
       <p:grpSpPr/>
       <p:sp>
         <p:nvSpPr>
-          <p:cNvPr id="2" name="TextBox 1"/>
+          <p:cNvPr id="2" name="Rectangle 1"/>
+          <p:cNvSpPr/>
+          <p:nvPr/>
+        </p:nvSpPr>
+        <p:spPr>
+          <a:xfrm>
+            <a:off x="0" y="0"/>
+            <a:ext cx="12191695" cy="1051560"/>
+          </a:xfrm>
+          <a:prstGeom prst="rect">
+            <a:avLst/>
+          </a:prstGeom>
+          <a:solidFill>
+            <a:srgbClr val="121821"/>
+          </a:solidFill>
+          <a:ln>
+            <a:noFill/>
+          </a:ln>
+        </p:spPr>
+        <p:style>
+          <a:lnRef idx="1">
+            <a:schemeClr val="accent1"/>
+          </a:lnRef>
+          <a:fillRef idx="3">
+            <a:schemeClr val="accent1"/>
+          </a:fillRef>
+          <a:effectRef idx="2">
+            <a:schemeClr val="accent1"/>
+          </a:effectRef>
+          <a:fontRef idx="minor">
+            <a:schemeClr val="lt1"/>
+          </a:fontRef>
+        </p:style>
+        <p:txBody>
+          <a:bodyPr rtlCol="0" anchor="ctr"/>
+          <a:lstStyle/>
+          <a:p>
+            <a:pPr algn="ctr"/>
+          </a:p>
+        </p:txBody>
+      </p:sp>
+      <p:sp>
+        <p:nvSpPr>
+          <p:cNvPr id="3" name="Rectangle 2"/>
+          <p:cNvSpPr/>
+          <p:nvPr/>
+        </p:nvSpPr>
+        <p:spPr>
+          <a:xfrm>
+            <a:off x="0" y="0"/>
+            <a:ext cx="12191695" cy="73152"/>
+          </a:xfrm>
+          <a:prstGeom prst="rect">
+            <a:avLst/>
+          </a:prstGeom>
+          <a:solidFill>
+            <a:srgbClr val="00E676"/>
+          </a:solidFill>
+          <a:ln>
+            <a:noFill/>
+          </a:ln>
+        </p:spPr>
+        <p:style>
+          <a:lnRef idx="1">
+            <a:schemeClr val="accent1"/>
+          </a:lnRef>
+          <a:fillRef idx="3">
+            <a:schemeClr val="accent1"/>
+          </a:fillRef>
+          <a:effectRef idx="2">
+            <a:schemeClr val="accent1"/>
+          </a:effectRef>
+          <a:fontRef idx="minor">
+            <a:schemeClr val="lt1"/>
+          </a:fontRef>
+        </p:style>
+        <p:txBody>
+          <a:bodyPr rtlCol="0" anchor="ctr"/>
+          <a:lstStyle/>
+          <a:p>
+            <a:pPr algn="ctr"/>
+          </a:p>
+        </p:txBody>
+      </p:sp>
+      <p:sp>
+        <p:nvSpPr>
+          <p:cNvPr id="4" name="Rounded Rectangle 3"/>
+          <p:cNvSpPr/>
+          <p:nvPr/>
+        </p:nvSpPr>
+        <p:spPr>
+          <a:xfrm>
+            <a:off x="9784080" y="201168"/>
+            <a:ext cx="1691640" cy="502920"/>
+          </a:xfrm>
+          <a:prstGeom prst="roundRect">
+            <a:avLst/>
+          </a:prstGeom>
+          <a:solidFill>
+            <a:srgbClr val="388BFD"/>
+          </a:solidFill>
+          <a:ln>
+            <a:noFill/>
+          </a:ln>
+        </p:spPr>
+        <p:style>
+          <a:lnRef idx="1">
+            <a:schemeClr val="accent1"/>
+          </a:lnRef>
+          <a:fillRef idx="3">
+            <a:schemeClr val="accent1"/>
+          </a:fillRef>
+          <a:effectRef idx="2">
+            <a:schemeClr val="accent1"/>
+          </a:effectRef>
+          <a:fontRef idx="minor">
+            <a:schemeClr val="lt1"/>
+          </a:fontRef>
+        </p:style>
+        <p:txBody>
+          <a:bodyPr rtlCol="0" anchor="ctr"/>
+          <a:lstStyle/>
+          <a:p>
+            <a:pPr algn="ctr"/>
+          </a:p>
+        </p:txBody>
+      </p:sp>
+      <p:sp>
+        <p:nvSpPr>
+          <p:cNvPr id="5" name="Rounded Rectangle 4"/>
+          <p:cNvSpPr/>
+          <p:nvPr/>
+        </p:nvSpPr>
+        <p:spPr>
+          <a:xfrm>
+            <a:off x="502920" y="1325880"/>
+            <a:ext cx="11155680" cy="5257800"/>
+          </a:xfrm>
+          <a:prstGeom prst="roundRect">
+            <a:avLst/>
+          </a:prstGeom>
+          <a:solidFill>
+            <a:srgbClr val="161B22"/>
+          </a:solidFill>
+          <a:ln w="12700">
+            <a:solidFill>
+              <a:srgbClr val="308C64"/>
+            </a:solidFill>
+          </a:ln>
+        </p:spPr>
+        <p:style>
+          <a:lnRef idx="1">
+            <a:schemeClr val="accent1"/>
+          </a:lnRef>
+          <a:fillRef idx="3">
+            <a:schemeClr val="accent1"/>
+          </a:fillRef>
+          <a:effectRef idx="2">
+            <a:schemeClr val="accent1"/>
+          </a:effectRef>
+          <a:fontRef idx="minor">
+            <a:schemeClr val="lt1"/>
+          </a:fontRef>
+        </p:style>
+        <p:txBody>
+          <a:bodyPr rtlCol="0" anchor="ctr"/>
+          <a:lstStyle/>
+          <a:p>
+            <a:pPr algn="ctr"/>
+          </a:p>
+        </p:txBody>
+      </p:sp>
+      <p:sp>
+        <p:nvSpPr>
+          <p:cNvPr id="6" name="TextBox 5"/>
           <p:cNvSpPr txBox="1"/>
           <p:nvPr/>
         </p:nvSpPr>
         <p:spPr>
           <a:xfrm>
-            <a:off x="685800" y="502920"/>
-            <a:ext cx="10789920" cy="1005840"/>
+            <a:off x="713232" y="246888"/>
+            <a:ext cx="9692640" cy="777240"/>
           </a:xfrm>
           <a:prstGeom prst="rect">
             <a:avLst/>
@@ -5439,11 +7353,11 @@
           <a:lstStyle/>
           <a:p>
             <a:pPr>
-              <a:defRPr sz="3400" b="1">
+              <a:defRPr sz="3000" b="1">
                 <a:solidFill>
                   <a:srgbClr val="FFFFFF"/>
                 </a:solidFill>
-                <a:latin typeface="Arial"/>
+                <a:latin typeface="Calibri"/>
               </a:defRPr>
             </a:pPr>
             <a:r>
@@ -5454,14 +7368,14 @@
       </p:sp>
       <p:sp>
         <p:nvSpPr>
-          <p:cNvPr id="3" name="TextBox 2"/>
+          <p:cNvPr id="7" name="TextBox 6"/>
           <p:cNvSpPr txBox="1"/>
           <p:nvPr/>
         </p:nvSpPr>
         <p:spPr>
           <a:xfrm>
-            <a:off x="685800" y="1645920"/>
-            <a:ext cx="10789920" cy="4892040"/>
+            <a:off x="804672" y="1627632"/>
+            <a:ext cx="10561320" cy="4681728"/>
           </a:xfrm>
           <a:prstGeom prst="rect">
             <a:avLst/>
@@ -5476,13 +7390,13 @@
           <a:p>
             <a:pPr>
               <a:spcAft>
-                <a:spcPts val="700"/>
-              </a:spcAft>
-              <a:defRPr sz="2300" b="1">
+                <a:spcPts val="600"/>
+              </a:spcAft>
+              <a:defRPr sz="2200" b="1">
                 <a:solidFill>
                   <a:srgbClr val="00E676"/>
                 </a:solidFill>
-                <a:latin typeface="Arial"/>
+                <a:latin typeface="Calibri"/>
               </a:defRPr>
             </a:pPr>
             <a:r>
@@ -5492,13 +7406,13 @@
           <a:p>
             <a:pPr>
               <a:spcAft>
-                <a:spcPts val="700"/>
-              </a:spcAft>
-              <a:defRPr sz="2300" b="1">
+                <a:spcPts val="600"/>
+              </a:spcAft>
+              <a:defRPr sz="2200" b="1">
                 <a:solidFill>
                   <a:srgbClr val="00E676"/>
                 </a:solidFill>
-                <a:latin typeface="Arial"/>
+                <a:latin typeface="Calibri"/>
               </a:defRPr>
             </a:pPr>
             <a:r>
@@ -5508,26 +7422,26 @@
           <a:p>
             <a:pPr>
               <a:spcAft>
-                <a:spcPts val="700"/>
-              </a:spcAft>
-              <a:defRPr sz="1700">
-                <a:solidFill>
-                  <a:srgbClr val="B4B9C3"/>
-                </a:solidFill>
-                <a:latin typeface="Arial"/>
-              </a:defRPr>
-            </a:pPr>
-          </a:p>
-          <a:p>
-            <a:pPr>
-              <a:spcAft>
-                <a:spcPts val="700"/>
-              </a:spcAft>
-              <a:defRPr sz="1700">
-                <a:solidFill>
-                  <a:srgbClr val="B4B9C3"/>
-                </a:solidFill>
-                <a:latin typeface="Arial"/>
+                <a:spcPts val="600"/>
+              </a:spcAft>
+              <a:defRPr sz="1600">
+                <a:solidFill>
+                  <a:srgbClr val="C9D1D9"/>
+                </a:solidFill>
+                <a:latin typeface="Calibri"/>
+              </a:defRPr>
+            </a:pPr>
+          </a:p>
+          <a:p>
+            <a:pPr>
+              <a:spcAft>
+                <a:spcPts val="600"/>
+              </a:spcAft>
+              <a:defRPr sz="1600">
+                <a:solidFill>
+                  <a:srgbClr val="C9D1D9"/>
+                </a:solidFill>
+                <a:latin typeface="Calibri"/>
               </a:defRPr>
             </a:pPr>
             <a:r>
@@ -5537,13 +7451,13 @@
           <a:p>
             <a:pPr>
               <a:spcAft>
-                <a:spcPts val="700"/>
-              </a:spcAft>
-              <a:defRPr sz="1700">
-                <a:solidFill>
-                  <a:srgbClr val="B4B9C3"/>
-                </a:solidFill>
-                <a:latin typeface="Arial"/>
+                <a:spcPts val="600"/>
+              </a:spcAft>
+              <a:defRPr sz="1600">
+                <a:solidFill>
+                  <a:srgbClr val="C9D1D9"/>
+                </a:solidFill>
+                <a:latin typeface="Calibri"/>
               </a:defRPr>
             </a:pPr>
             <a:r>
@@ -5553,13 +7467,13 @@
           <a:p>
             <a:pPr>
               <a:spcAft>
-                <a:spcPts val="700"/>
-              </a:spcAft>
-              <a:defRPr sz="1700">
-                <a:solidFill>
-                  <a:srgbClr val="B4B9C3"/>
-                </a:solidFill>
-                <a:latin typeface="Arial"/>
+                <a:spcPts val="600"/>
+              </a:spcAft>
+              <a:defRPr sz="1600">
+                <a:solidFill>
+                  <a:srgbClr val="C9D1D9"/>
+                </a:solidFill>
+                <a:latin typeface="Calibri"/>
               </a:defRPr>
             </a:pPr>
             <a:r>
@@ -5569,13 +7483,13 @@
           <a:p>
             <a:pPr>
               <a:spcAft>
-                <a:spcPts val="700"/>
-              </a:spcAft>
-              <a:defRPr sz="1700">
-                <a:solidFill>
-                  <a:srgbClr val="B4B9C3"/>
-                </a:solidFill>
-                <a:latin typeface="Arial"/>
+                <a:spcPts val="600"/>
+              </a:spcAft>
+              <a:defRPr sz="1600">
+                <a:solidFill>
+                  <a:srgbClr val="C9D1D9"/>
+                </a:solidFill>
+                <a:latin typeface="Calibri"/>
               </a:defRPr>
             </a:pPr>
             <a:r>

</xml_diff>